<commit_message>
Procesteknolog: mindre opgave med ChatGPT i Excel
Fanen Opgave har nu kun de tre spørgsmål fra Opgave 13 for 13 batches.
Opgavearket beder dem åbne ChatGPT i Excel, bede om formlerne og tjekke
T-07, T-09 og T-11 mod deres egen udregning. Slides og plan fulgt med.

Co-Authored-By: Claude Fable 5.1 <noreply@anthropic.com>
Claude-Session: https://claude.ai/code/session_015YJpkwAMXruZRjbkCwcfYy
</commit_message>
<xml_diff>
--- a/private/proces/praesentation.pptx
+++ b/private/proces/praesentation.pptx
@@ -160,7 +160,7 @@
   <p:extLst>
     <p:ext uri="{521415D9-36F7-43E2-AB2F-B90AF26B5E84}">
       <p14:sectionLst xmlns:p14="http://schemas.microsoft.com/office/powerpoint/2010/main">
-        <p14:section name="Åbning" id="{37a56dbc-08fb-18e0-62dd-144bb924d651}">
+        <p14:section name="Åbning" id="{017ba0d1-656e-1d29-a133-a7e0006808df}">
           <p14:sldIdLst>
             <p14:sldId id="256"/>
             <p14:sldId id="257"/>
@@ -170,7 +170,7 @@
             <p14:sldId id="261"/>
           </p14:sldIdLst>
         </p14:section>
-        <p14:section name="Som studerende" id="{2c047dd9-4845-8124-15a0-3af8ade347a9}">
+        <p14:section name="Som studerende" id="{2f6c7a6d-079d-ce48-9a6e-fd8f97de239c}">
           <p14:sldIdLst>
             <p14:sldId id="262"/>
             <p14:sldId id="263"/>
@@ -182,7 +182,7 @@
             <p14:sldId id="269"/>
           </p14:sldIdLst>
         </p14:section>
-        <p14:section name="Prompting" id="{1875b0d0-d77f-986d-e86e-85e0c1870720}">
+        <p14:section name="Prompting" id="{c11a35e7-89c4-f79b-9d54-e976c1224dcc}">
           <p14:sldIdLst>
             <p14:sldId id="270"/>
             <p14:sldId id="271"/>
@@ -193,7 +193,7 @@
             <p14:sldId id="276"/>
           </p14:sldIdLst>
         </p14:section>
-        <p14:section name="Excel og data" id="{596b254d-aa50-4bc3-08fd-37bff60be62f}">
+        <p14:section name="Excel og data" id="{cca4b236-cfc9-ca0d-8246-55f7013eca91}">
           <p14:sldIdLst>
             <p14:sldId id="277"/>
             <p14:sldId id="278"/>
@@ -212,7 +212,7 @@
             <p14:sldId id="291"/>
           </p14:sldIdLst>
         </p14:section>
-        <p14:section name="AI i jobbet" id="{25599eb2-7557-c594-add7-ddda8f6e1f0b}">
+        <p14:section name="AI i jobbet" id="{88d2119a-6e71-3299-3de4-d40275150d8b}">
           <p14:sldIdLst>
             <p14:sldId id="292"/>
             <p14:sldId id="293"/>
@@ -225,7 +225,7 @@
             <p14:sldId id="300"/>
           </p14:sldIdLst>
         </p14:section>
-        <p14:section name="Vibecoding" id="{98262210-9851-e288-3dad-e9a84d8b7d24}">
+        <p14:section name="Vibecoding" id="{6b4b8213-4b5f-e44d-9caf-40efe0ecd097}">
           <p14:sldIdLst>
             <p14:sldId id="301"/>
             <p14:sldId id="302"/>
@@ -235,7 +235,7 @@
             <p14:sldId id="306"/>
           </p14:sldIdLst>
         </p14:section>
-        <p14:section name="Afrunding" id="{702dc821-5827-4dd1-ed1c-e203df7be9e0}">
+        <p14:section name="Afrunding" id="{8cf99049-23d7-2a05-7672-c377dd7a9551}">
           <p14:sldIdLst>
             <p14:sldId id="307"/>
             <p14:sldId id="308"/>
@@ -4501,7 +4501,7 @@
           <a:p>
             <a:r>
               <a:rPr lang="en-US" dirty="0"/>
-              <a:t>Opgaven i Excel. Fanen Opgave har de 14 batches og tomme kolonner. De studerende skriver selv formlerne i række 2 og trækker dem ned. Trin 1 til 7 er det vigtigste og svarer til de tre spørgsmål i Opgave 13. Tjekket er, at T-07 giver 13.816 kg vand, 107,9 kg i timen og 85,5 procent tørstof med 1.500 kg mere fjernet. AI må forklare formlerne og finde fejl, men de skriver selv. Facit-arket med formlerne ligger i mappen.</a:t>
+              <a:t>Opgaven i Excel. Fanen Opgave har 13 batches og tre tomme kolonner, der svarer til de tre spørgsmål i Opgave 13. De studerende åbner ChatGPT i Excel fra sidepanelet, beder om formlen til række 2, sætter den ind og trækker den ned. Tjekket er, at T-07 giver 13.816 kg vand, 107,9 kg i timen og 85,5 procent tørstof med 1.500 kg mere fjernet. Det er de tal, de selv regnede i Opgave 13. Prompterne står på opgavearket.</a:t>
             </a:r>
             <a:endParaRPr lang="en-US" dirty="0"/>
           </a:p>
@@ -4589,7 +4589,7 @@
           <a:p>
             <a:r>
               <a:rPr lang="en-US" dirty="0"/>
-              <a:t>Hands-on. Parvis bygger de massebalancen i fanen Opgave. Gå rundt og hjælp. Typiske fejl er procent som tal, manglende dollartegn på inputcellen og T-14, der ikke er færdig. Bagefter viser et par sit ark på storskærmen og tallene for T-07. Når regnestykket står i deres eget ark, må de lade AI lave det hele, som i demoen. Så kan de se, om AI regner rigtigt.</a:t>
+              <a:t>Hands-on. Parvis åbner de fanen Opgave og ChatGPT i Excel. Gå rundt og hjælp. Typiske problemer er login i tilføjelsen og procenter, der står som tal. Bagefter viser et par sit ark på storskærmen, tallene for T-07, og hvordan de tjekkede ChatGPT. Fejler tilføjelsen, så kør samme prompts i ChatGPT i browseren med filen uploadet.</a:t>
             </a:r>
             <a:endParaRPr lang="en-US" dirty="0"/>
           </a:p>
@@ -4677,7 +4677,7 @@
           <a:p>
             <a:r>
               <a:rPr lang="en-US" dirty="0"/>
-              <a:t>Pointen for Excel-delen. Den, der har bygget regnestykket selv, kan stille AI den rigtige opgave og se, om svaret er rigtigt. I jobbet stiller I spørgsmålet, og AI laver regnearbejdet.</a:t>
+              <a:t>Pointen for Excel-delen. AI skriver formlen på sekunder. Den, der kender regnestykket, kan se, om tallet passer. I jobbet stiller I spørgsmålet, og AI laver regnearbejdet.</a:t>
             </a:r>
             <a:endParaRPr lang="en-US" dirty="0"/>
           </a:p>
@@ -19348,7 +19348,7 @@
                   <a:schemeClr val="bg1"/>
                 </a:solidFill>
               </a:rPr>
-              <a:t>Byg regnestykket én gang. </a:t>
+              <a:t>Tre spørgsmål. </a:t>
             </a:r>
             <a:pPr algn="l" indent="0" marL="0">
               <a:lnSpc>
@@ -19362,7 +19362,7 @@
                   <a:schemeClr val="accent1"/>
                 </a:solidFill>
               </a:rPr>
-              <a:t>Træk det ned.</a:t>
+              <a:t>ChatGPT skriver formlerne</a:t>
             </a:r>
             <a:endParaRPr lang="en-US" sz="3400" dirty="0"/>
           </a:p>
@@ -19393,12 +19393,156 @@
               <a:buNone/>
             </a:pPr>
             <a:r>
+              <a:rPr lang="en-US" sz="2800" b="1" dirty="0">
+                <a:solidFill>
+                  <a:schemeClr val="accent1"/>
+                </a:solidFill>
+              </a:rPr>
+              <a:t>1</a:t>
+            </a:r>
+            <a:endParaRPr lang="en-US" sz="2800" dirty="0"/>
+          </a:p>
+        </p:txBody>
+      </p:sp>
+      <p:sp>
+        <p:nvSpPr>
+          <p:cNvPr id="5" name="Text 3"/>
+          <p:cNvSpPr txBox="1"/>
+          <p:nvPr/>
+        </p:nvSpPr>
+        <p:spPr>
+          <a:xfrm>
+            <a:off x="1417320" y="2350008"/>
+            <a:ext cx="6583680" cy="457200"/>
+          </a:xfrm>
+          <a:prstGeom prst="rect">
+            <a:avLst/>
+          </a:prstGeom>
+          <a:noFill/>
+          <a:ln/>
+        </p:spPr>
+        <p:txBody>
+          <a:bodyPr wrap="square" lIns="0" tIns="0" rIns="0" bIns="0" rtlCol="0" anchor="t"/>
+          <a:lstStyle/>
+          <a:p>
+            <a:pPr indent="0" marL="0">
+              <a:buNone/>
+            </a:pPr>
+            <a:r>
               <a:rPr lang="en-US" sz="2600" b="1" dirty="0">
                 <a:solidFill>
+                  <a:schemeClr val="bg1"/>
+                </a:solidFill>
+              </a:rPr>
+              <a:t>Vand fjernet i kg</a:t>
+            </a:r>
+            <a:endParaRPr lang="en-US" sz="2600" dirty="0"/>
+          </a:p>
+        </p:txBody>
+      </p:sp>
+      <p:sp>
+        <p:nvSpPr>
+          <p:cNvPr id="6" name="Text 4"/>
+          <p:cNvSpPr txBox="1"/>
+          <p:nvPr/>
+        </p:nvSpPr>
+        <p:spPr>
+          <a:xfrm>
+            <a:off x="1417320" y="2807208"/>
+            <a:ext cx="6583680" cy="320040"/>
+          </a:xfrm>
+          <a:prstGeom prst="rect">
+            <a:avLst/>
+          </a:prstGeom>
+          <a:noFill/>
+          <a:ln/>
+        </p:spPr>
+        <p:txBody>
+          <a:bodyPr wrap="square" lIns="0" tIns="0" rIns="0" bIns="0" rtlCol="0" anchor="t"/>
+          <a:lstStyle/>
+          <a:p>
+            <a:pPr indent="0" marL="0">
+              <a:buNone/>
+            </a:pPr>
+            <a:r>
+              <a:rPr lang="en-US" sz="1500" dirty="0">
+                <a:solidFill>
+                  <a:schemeClr val="accent3"/>
+                </a:solidFill>
+              </a:rPr>
+              <a:t>T-07 giver 13.816 kg</a:t>
+            </a:r>
+            <a:endParaRPr lang="en-US" sz="1500" dirty="0"/>
+          </a:p>
+        </p:txBody>
+      </p:sp>
+      <p:sp>
+        <p:nvSpPr>
+          <p:cNvPr id="7" name="Text 5"/>
+          <p:cNvSpPr txBox="1"/>
+          <p:nvPr/>
+        </p:nvSpPr>
+        <p:spPr>
+          <a:xfrm>
+            <a:off x="685800" y="3337560"/>
+            <a:ext cx="548640" cy="457200"/>
+          </a:xfrm>
+          <a:prstGeom prst="rect">
+            <a:avLst/>
+          </a:prstGeom>
+          <a:noFill/>
+          <a:ln/>
+        </p:spPr>
+        <p:txBody>
+          <a:bodyPr wrap="square" lIns="0" tIns="0" rIns="0" bIns="0" rtlCol="0" anchor="t"/>
+          <a:lstStyle/>
+          <a:p>
+            <a:pPr indent="0" marL="0">
+              <a:buNone/>
+            </a:pPr>
+            <a:r>
+              <a:rPr lang="en-US" sz="2800" b="1" dirty="0">
+                <a:solidFill>
                   <a:schemeClr val="accent1"/>
                 </a:solidFill>
               </a:rPr>
-              <a:t>1</a:t>
+              <a:t>2</a:t>
+            </a:r>
+            <a:endParaRPr lang="en-US" sz="2800" dirty="0"/>
+          </a:p>
+        </p:txBody>
+      </p:sp>
+      <p:sp>
+        <p:nvSpPr>
+          <p:cNvPr id="8" name="Text 6"/>
+          <p:cNvSpPr txBox="1"/>
+          <p:nvPr/>
+        </p:nvSpPr>
+        <p:spPr>
+          <a:xfrm>
+            <a:off x="1417320" y="3355848"/>
+            <a:ext cx="6583680" cy="457200"/>
+          </a:xfrm>
+          <a:prstGeom prst="rect">
+            <a:avLst/>
+          </a:prstGeom>
+          <a:noFill/>
+          <a:ln/>
+        </p:spPr>
+        <p:txBody>
+          <a:bodyPr wrap="square" lIns="0" tIns="0" rIns="0" bIns="0" rtlCol="0" anchor="t"/>
+          <a:lstStyle/>
+          <a:p>
+            <a:pPr indent="0" marL="0">
+              <a:buNone/>
+            </a:pPr>
+            <a:r>
+              <a:rPr lang="en-US" sz="2600" b="1" dirty="0">
+                <a:solidFill>
+                  <a:schemeClr val="bg1"/>
+                </a:solidFill>
+              </a:rPr>
+              <a:t>Vand pr. time</a:t>
             </a:r>
             <a:endParaRPr lang="en-US" sz="2600" dirty="0"/>
           </a:p>
@@ -19406,50 +19550,257 @@
       </p:sp>
       <p:sp>
         <p:nvSpPr>
-          <p:cNvPr id="5" name="Text 3"/>
-          <p:cNvSpPr txBox="1"/>
-          <p:nvPr/>
-        </p:nvSpPr>
-        <p:spPr>
-          <a:xfrm>
-            <a:off x="1325880" y="2350008"/>
-            <a:ext cx="4663440" cy="411480"/>
-          </a:xfrm>
-          <a:prstGeom prst="rect">
-            <a:avLst/>
-          </a:prstGeom>
-          <a:noFill/>
-          <a:ln/>
-        </p:spPr>
-        <p:txBody>
-          <a:bodyPr wrap="square" lIns="0" tIns="0" rIns="0" bIns="0" rtlCol="0" anchor="t"/>
-          <a:lstStyle/>
-          <a:p>
-            <a:pPr indent="0" marL="0">
-              <a:buNone/>
-            </a:pPr>
-            <a:r>
-              <a:rPr lang="en-US" sz="2400" b="1" dirty="0">
+          <p:cNvPr id="9" name="Text 7"/>
+          <p:cNvSpPr txBox="1"/>
+          <p:nvPr/>
+        </p:nvSpPr>
+        <p:spPr>
+          <a:xfrm>
+            <a:off x="1417320" y="3813048"/>
+            <a:ext cx="6583680" cy="320040"/>
+          </a:xfrm>
+          <a:prstGeom prst="rect">
+            <a:avLst/>
+          </a:prstGeom>
+          <a:noFill/>
+          <a:ln/>
+        </p:spPr>
+        <p:txBody>
+          <a:bodyPr wrap="square" lIns="0" tIns="0" rIns="0" bIns="0" rtlCol="0" anchor="t"/>
+          <a:lstStyle/>
+          <a:p>
+            <a:pPr indent="0" marL="0">
+              <a:buNone/>
+            </a:pPr>
+            <a:r>
+              <a:rPr lang="en-US" sz="1500" dirty="0">
+                <a:solidFill>
+                  <a:schemeClr val="accent3"/>
+                </a:solidFill>
+              </a:rPr>
+              <a:t>T-07 giver 107,9 kg</a:t>
+            </a:r>
+            <a:endParaRPr lang="en-US" sz="1500" dirty="0"/>
+          </a:p>
+        </p:txBody>
+      </p:sp>
+      <p:sp>
+        <p:nvSpPr>
+          <p:cNvPr id="10" name="Text 8"/>
+          <p:cNvSpPr txBox="1"/>
+          <p:nvPr/>
+        </p:nvSpPr>
+        <p:spPr>
+          <a:xfrm>
+            <a:off x="685800" y="4343400"/>
+            <a:ext cx="548640" cy="457200"/>
+          </a:xfrm>
+          <a:prstGeom prst="rect">
+            <a:avLst/>
+          </a:prstGeom>
+          <a:noFill/>
+          <a:ln/>
+        </p:spPr>
+        <p:txBody>
+          <a:bodyPr wrap="square" lIns="0" tIns="0" rIns="0" bIns="0" rtlCol="0" anchor="t"/>
+          <a:lstStyle/>
+          <a:p>
+            <a:pPr indent="0" marL="0">
+              <a:buNone/>
+            </a:pPr>
+            <a:r>
+              <a:rPr lang="en-US" sz="2800" b="1" dirty="0">
+                <a:solidFill>
+                  <a:schemeClr val="accent1"/>
+                </a:solidFill>
+              </a:rPr>
+              <a:t>3</a:t>
+            </a:r>
+            <a:endParaRPr lang="en-US" sz="2800" dirty="0"/>
+          </a:p>
+        </p:txBody>
+      </p:sp>
+      <p:sp>
+        <p:nvSpPr>
+          <p:cNvPr id="11" name="Text 9"/>
+          <p:cNvSpPr txBox="1"/>
+          <p:nvPr/>
+        </p:nvSpPr>
+        <p:spPr>
+          <a:xfrm>
+            <a:off x="1417320" y="4361688"/>
+            <a:ext cx="6583680" cy="457200"/>
+          </a:xfrm>
+          <a:prstGeom prst="rect">
+            <a:avLst/>
+          </a:prstGeom>
+          <a:noFill/>
+          <a:ln/>
+        </p:spPr>
+        <p:txBody>
+          <a:bodyPr wrap="square" lIns="0" tIns="0" rIns="0" bIns="0" rtlCol="0" anchor="t"/>
+          <a:lstStyle/>
+          <a:p>
+            <a:pPr indent="0" marL="0">
+              <a:buNone/>
+            </a:pPr>
+            <a:r>
+              <a:rPr lang="en-US" sz="2600" b="1" dirty="0">
                 <a:solidFill>
                   <a:schemeClr val="bg1"/>
                 </a:solidFill>
               </a:rPr>
-              <a:t>Timer</a:t>
-            </a:r>
-            <a:endParaRPr lang="en-US" sz="2400" dirty="0"/>
-          </a:p>
-        </p:txBody>
-      </p:sp>
-      <p:sp>
-        <p:nvSpPr>
-          <p:cNvPr id="6" name="Text 4"/>
-          <p:cNvSpPr txBox="1"/>
-          <p:nvPr/>
-        </p:nvSpPr>
-        <p:spPr>
-          <a:xfrm>
-            <a:off x="1325880" y="2770632"/>
-            <a:ext cx="4663440" cy="320040"/>
+              <a:t>Tørstof med ekstra vand fjernet</a:t>
+            </a:r>
+            <a:endParaRPr lang="en-US" sz="2600" dirty="0"/>
+          </a:p>
+        </p:txBody>
+      </p:sp>
+      <p:sp>
+        <p:nvSpPr>
+          <p:cNvPr id="12" name="Text 10"/>
+          <p:cNvSpPr txBox="1"/>
+          <p:nvPr/>
+        </p:nvSpPr>
+        <p:spPr>
+          <a:xfrm>
+            <a:off x="1417320" y="4818888"/>
+            <a:ext cx="6583680" cy="320040"/>
+          </a:xfrm>
+          <a:prstGeom prst="rect">
+            <a:avLst/>
+          </a:prstGeom>
+          <a:noFill/>
+          <a:ln/>
+        </p:spPr>
+        <p:txBody>
+          <a:bodyPr wrap="square" lIns="0" tIns="0" rIns="0" bIns="0" rtlCol="0" anchor="t"/>
+          <a:lstStyle/>
+          <a:p>
+            <a:pPr indent="0" marL="0">
+              <a:buNone/>
+            </a:pPr>
+            <a:r>
+              <a:rPr lang="en-US" sz="1500" dirty="0">
+                <a:solidFill>
+                  <a:schemeClr val="accent3"/>
+                </a:solidFill>
+              </a:rPr>
+              <a:t>T-07 giver 85,5 %</a:t>
+            </a:r>
+            <a:endParaRPr lang="en-US" sz="1500" dirty="0"/>
+          </a:p>
+        </p:txBody>
+      </p:sp>
+      <p:sp>
+        <p:nvSpPr>
+          <p:cNvPr id="13" name="Shape 11"/>
+          <p:cNvSpPr/>
+          <p:nvPr/>
+        </p:nvSpPr>
+        <p:spPr>
+          <a:xfrm>
+            <a:off x="8229600" y="2286000"/>
+            <a:ext cx="3273552" cy="3017520"/>
+          </a:xfrm>
+          <a:prstGeom prst="roundRect">
+            <a:avLst>
+              <a:gd name="adj" fmla="val 3636"/>
+            </a:avLst>
+          </a:prstGeom>
+          <a:solidFill>
+            <a:schemeClr val="accent6"/>
+          </a:solidFill>
+          <a:ln w="12700">
+            <a:solidFill>
+              <a:schemeClr val="accent6"/>
+            </a:solidFill>
+            <a:prstDash val="solid"/>
+          </a:ln>
+        </p:spPr>
+      </p:sp>
+      <p:sp>
+        <p:nvSpPr>
+          <p:cNvPr id="14" name="Text 12"/>
+          <p:cNvSpPr txBox="1"/>
+          <p:nvPr/>
+        </p:nvSpPr>
+        <p:spPr>
+          <a:xfrm>
+            <a:off x="8503920" y="2560320"/>
+            <a:ext cx="2743200" cy="274320"/>
+          </a:xfrm>
+          <a:prstGeom prst="rect">
+            <a:avLst/>
+          </a:prstGeom>
+          <a:noFill/>
+          <a:ln/>
+        </p:spPr>
+        <p:txBody>
+          <a:bodyPr wrap="square" lIns="0" tIns="0" rIns="0" bIns="0" rtlCol="0" anchor="t"/>
+          <a:lstStyle/>
+          <a:p>
+            <a:pPr indent="0" marL="0">
+              <a:buNone/>
+            </a:pPr>
+            <a:r>
+              <a:rPr lang="en-US" sz="1100" b="1" spc="200" kern="0" dirty="0">
+                <a:solidFill>
+                  <a:schemeClr val="accent1"/>
+                </a:solidFill>
+              </a:rPr>
+              <a:t>SÅDAN</a:t>
+            </a:r>
+            <a:endParaRPr lang="en-US" sz="1100" dirty="0"/>
+          </a:p>
+        </p:txBody>
+      </p:sp>
+      <p:sp>
+        <p:nvSpPr>
+          <p:cNvPr id="15" name="Text 13"/>
+          <p:cNvSpPr txBox="1"/>
+          <p:nvPr/>
+        </p:nvSpPr>
+        <p:spPr>
+          <a:xfrm>
+            <a:off x="8503920" y="2926080"/>
+            <a:ext cx="2743200" cy="1463040"/>
+          </a:xfrm>
+          <a:prstGeom prst="rect">
+            <a:avLst/>
+          </a:prstGeom>
+          <a:noFill/>
+          <a:ln/>
+        </p:spPr>
+        <p:txBody>
+          <a:bodyPr wrap="square" lIns="0" tIns="0" rIns="0" bIns="0" rtlCol="0" anchor="t"/>
+          <a:lstStyle/>
+          <a:p>
+            <a:pPr indent="0" marL="0">
+              <a:buNone/>
+            </a:pPr>
+            <a:r>
+              <a:rPr lang="en-US" sz="1500" dirty="0">
+                <a:solidFill>
+                  <a:schemeClr val="bg1"/>
+                </a:solidFill>
+              </a:rPr>
+              <a:t>Åbn ChatGPT i Excel under Hjem og Tilføjelsesprogrammer. Bed om formlen til række 2, sæt den ind, og træk den ned.</a:t>
+            </a:r>
+            <a:endParaRPr lang="en-US" sz="1500" dirty="0"/>
+          </a:p>
+        </p:txBody>
+      </p:sp>
+      <p:sp>
+        <p:nvSpPr>
+          <p:cNvPr id="16" name="Text 14"/>
+          <p:cNvSpPr txBox="1"/>
+          <p:nvPr/>
+        </p:nvSpPr>
+        <p:spPr>
+          <a:xfrm>
+            <a:off x="8503920" y="4434840"/>
+            <a:ext cx="2743200" cy="640080"/>
           </a:xfrm>
           <a:prstGeom prst="rect">
             <a:avLst/>
@@ -19470,7 +19821,7 @@
                   <a:schemeClr val="accent3"/>
                 </a:solidFill>
               </a:rPr>
-              <a:t>Slut minus start, gange 24</a:t>
+              <a:t>Tjek T-07 mod jeres egen udregning.</a:t>
             </a:r>
             <a:endParaRPr lang="en-US" sz="1400" dirty="0"/>
           </a:p>
@@ -19478,763 +19829,7 @@
       </p:sp>
       <p:sp>
         <p:nvSpPr>
-          <p:cNvPr id="7" name="Text 5"/>
-          <p:cNvSpPr txBox="1"/>
-          <p:nvPr/>
-        </p:nvSpPr>
-        <p:spPr>
-          <a:xfrm>
-            <a:off x="685800" y="3227832"/>
-            <a:ext cx="548640" cy="457200"/>
-          </a:xfrm>
-          <a:prstGeom prst="rect">
-            <a:avLst/>
-          </a:prstGeom>
-          <a:noFill/>
-          <a:ln/>
-        </p:spPr>
-        <p:txBody>
-          <a:bodyPr wrap="square" lIns="0" tIns="0" rIns="0" bIns="0" rtlCol="0" anchor="t"/>
-          <a:lstStyle/>
-          <a:p>
-            <a:pPr indent="0" marL="0">
-              <a:buNone/>
-            </a:pPr>
-            <a:r>
-              <a:rPr lang="en-US" sz="2600" b="1" dirty="0">
-                <a:solidFill>
-                  <a:schemeClr val="accent1"/>
-                </a:solidFill>
-              </a:rPr>
-              <a:t>2</a:t>
-            </a:r>
-            <a:endParaRPr lang="en-US" sz="2600" dirty="0"/>
-          </a:p>
-        </p:txBody>
-      </p:sp>
-      <p:sp>
-        <p:nvSpPr>
-          <p:cNvPr id="8" name="Text 6"/>
-          <p:cNvSpPr txBox="1"/>
-          <p:nvPr/>
-        </p:nvSpPr>
-        <p:spPr>
-          <a:xfrm>
-            <a:off x="1325880" y="3246120"/>
-            <a:ext cx="4663440" cy="411480"/>
-          </a:xfrm>
-          <a:prstGeom prst="rect">
-            <a:avLst/>
-          </a:prstGeom>
-          <a:noFill/>
-          <a:ln/>
-        </p:spPr>
-        <p:txBody>
-          <a:bodyPr wrap="square" lIns="0" tIns="0" rIns="0" bIns="0" rtlCol="0" anchor="t"/>
-          <a:lstStyle/>
-          <a:p>
-            <a:pPr indent="0" marL="0">
-              <a:buNone/>
-            </a:pPr>
-            <a:r>
-              <a:rPr lang="en-US" sz="2400" b="1" dirty="0">
-                <a:solidFill>
-                  <a:schemeClr val="bg1"/>
-                </a:solidFill>
-              </a:rPr>
-              <a:t>Tørstof</a:t>
-            </a:r>
-            <a:endParaRPr lang="en-US" sz="2400" dirty="0"/>
-          </a:p>
-        </p:txBody>
-      </p:sp>
-      <p:sp>
-        <p:nvSpPr>
-          <p:cNvPr id="9" name="Text 7"/>
-          <p:cNvSpPr txBox="1"/>
-          <p:nvPr/>
-        </p:nvSpPr>
-        <p:spPr>
-          <a:xfrm>
-            <a:off x="1325880" y="3666744"/>
-            <a:ext cx="4663440" cy="320040"/>
-          </a:xfrm>
-          <a:prstGeom prst="rect">
-            <a:avLst/>
-          </a:prstGeom>
-          <a:noFill/>
-          <a:ln/>
-        </p:spPr>
-        <p:txBody>
-          <a:bodyPr wrap="square" lIns="0" tIns="0" rIns="0" bIns="0" rtlCol="0" anchor="t"/>
-          <a:lstStyle/>
-          <a:p>
-            <a:pPr indent="0" marL="0">
-              <a:buNone/>
-            </a:pPr>
-            <a:r>
-              <a:rPr lang="en-US" sz="1400" dirty="0">
-                <a:solidFill>
-                  <a:schemeClr val="accent3"/>
-                </a:solidFill>
-              </a:rPr>
-              <a:t>Ind gange (1 minus vand ind)</a:t>
-            </a:r>
-            <a:endParaRPr lang="en-US" sz="1400" dirty="0"/>
-          </a:p>
-        </p:txBody>
-      </p:sp>
-      <p:sp>
-        <p:nvSpPr>
-          <p:cNvPr id="10" name="Text 8"/>
-          <p:cNvSpPr txBox="1"/>
-          <p:nvPr/>
-        </p:nvSpPr>
-        <p:spPr>
-          <a:xfrm>
-            <a:off x="685800" y="4123944"/>
-            <a:ext cx="548640" cy="457200"/>
-          </a:xfrm>
-          <a:prstGeom prst="rect">
-            <a:avLst/>
-          </a:prstGeom>
-          <a:noFill/>
-          <a:ln/>
-        </p:spPr>
-        <p:txBody>
-          <a:bodyPr wrap="square" lIns="0" tIns="0" rIns="0" bIns="0" rtlCol="0" anchor="t"/>
-          <a:lstStyle/>
-          <a:p>
-            <a:pPr indent="0" marL="0">
-              <a:buNone/>
-            </a:pPr>
-            <a:r>
-              <a:rPr lang="en-US" sz="2600" b="1" dirty="0">
-                <a:solidFill>
-                  <a:schemeClr val="accent1"/>
-                </a:solidFill>
-              </a:rPr>
-              <a:t>3</a:t>
-            </a:r>
-            <a:endParaRPr lang="en-US" sz="2600" dirty="0"/>
-          </a:p>
-        </p:txBody>
-      </p:sp>
-      <p:sp>
-        <p:nvSpPr>
-          <p:cNvPr id="11" name="Text 9"/>
-          <p:cNvSpPr txBox="1"/>
-          <p:nvPr/>
-        </p:nvSpPr>
-        <p:spPr>
-          <a:xfrm>
-            <a:off x="1325880" y="4142232"/>
-            <a:ext cx="4663440" cy="411480"/>
-          </a:xfrm>
-          <a:prstGeom prst="rect">
-            <a:avLst/>
-          </a:prstGeom>
-          <a:noFill/>
-          <a:ln/>
-        </p:spPr>
-        <p:txBody>
-          <a:bodyPr wrap="square" lIns="0" tIns="0" rIns="0" bIns="0" rtlCol="0" anchor="t"/>
-          <a:lstStyle/>
-          <a:p>
-            <a:pPr indent="0" marL="0">
-              <a:buNone/>
-            </a:pPr>
-            <a:r>
-              <a:rPr lang="en-US" sz="2400" b="1" dirty="0">
-                <a:solidFill>
-                  <a:schemeClr val="bg1"/>
-                </a:solidFill>
-              </a:rPr>
-              <a:t>Masse ud</a:t>
-            </a:r>
-            <a:endParaRPr lang="en-US" sz="2400" dirty="0"/>
-          </a:p>
-        </p:txBody>
-      </p:sp>
-      <p:sp>
-        <p:nvSpPr>
-          <p:cNvPr id="12" name="Text 10"/>
-          <p:cNvSpPr txBox="1"/>
-          <p:nvPr/>
-        </p:nvSpPr>
-        <p:spPr>
-          <a:xfrm>
-            <a:off x="1325880" y="4562856"/>
-            <a:ext cx="4663440" cy="320040"/>
-          </a:xfrm>
-          <a:prstGeom prst="rect">
-            <a:avLst/>
-          </a:prstGeom>
-          <a:noFill/>
-          <a:ln/>
-        </p:spPr>
-        <p:txBody>
-          <a:bodyPr wrap="square" lIns="0" tIns="0" rIns="0" bIns="0" rtlCol="0" anchor="t"/>
-          <a:lstStyle/>
-          <a:p>
-            <a:pPr indent="0" marL="0">
-              <a:buNone/>
-            </a:pPr>
-            <a:r>
-              <a:rPr lang="en-US" sz="1400" dirty="0">
-                <a:solidFill>
-                  <a:schemeClr val="accent3"/>
-                </a:solidFill>
-              </a:rPr>
-              <a:t>Tørstof delt med (1 minus vand ud)</a:t>
-            </a:r>
-            <a:endParaRPr lang="en-US" sz="1400" dirty="0"/>
-          </a:p>
-        </p:txBody>
-      </p:sp>
-      <p:sp>
-        <p:nvSpPr>
-          <p:cNvPr id="13" name="Text 11"/>
-          <p:cNvSpPr txBox="1"/>
-          <p:nvPr/>
-        </p:nvSpPr>
-        <p:spPr>
-          <a:xfrm>
-            <a:off x="685800" y="5020056"/>
-            <a:ext cx="548640" cy="457200"/>
-          </a:xfrm>
-          <a:prstGeom prst="rect">
-            <a:avLst/>
-          </a:prstGeom>
-          <a:noFill/>
-          <a:ln/>
-        </p:spPr>
-        <p:txBody>
-          <a:bodyPr wrap="square" lIns="0" tIns="0" rIns="0" bIns="0" rtlCol="0" anchor="t"/>
-          <a:lstStyle/>
-          <a:p>
-            <a:pPr indent="0" marL="0">
-              <a:buNone/>
-            </a:pPr>
-            <a:r>
-              <a:rPr lang="en-US" sz="2600" b="1" dirty="0">
-                <a:solidFill>
-                  <a:schemeClr val="accent1"/>
-                </a:solidFill>
-              </a:rPr>
-              <a:t>4</a:t>
-            </a:r>
-            <a:endParaRPr lang="en-US" sz="2600" dirty="0"/>
-          </a:p>
-        </p:txBody>
-      </p:sp>
-      <p:sp>
-        <p:nvSpPr>
-          <p:cNvPr id="14" name="Text 12"/>
-          <p:cNvSpPr txBox="1"/>
-          <p:nvPr/>
-        </p:nvSpPr>
-        <p:spPr>
-          <a:xfrm>
-            <a:off x="1325880" y="5038344"/>
-            <a:ext cx="4663440" cy="411480"/>
-          </a:xfrm>
-          <a:prstGeom prst="rect">
-            <a:avLst/>
-          </a:prstGeom>
-          <a:noFill/>
-          <a:ln/>
-        </p:spPr>
-        <p:txBody>
-          <a:bodyPr wrap="square" lIns="0" tIns="0" rIns="0" bIns="0" rtlCol="0" anchor="t"/>
-          <a:lstStyle/>
-          <a:p>
-            <a:pPr indent="0" marL="0">
-              <a:buNone/>
-            </a:pPr>
-            <a:r>
-              <a:rPr lang="en-US" sz="2400" b="1" dirty="0">
-                <a:solidFill>
-                  <a:schemeClr val="bg1"/>
-                </a:solidFill>
-              </a:rPr>
-              <a:t>Vand fjernet</a:t>
-            </a:r>
-            <a:endParaRPr lang="en-US" sz="2400" dirty="0"/>
-          </a:p>
-        </p:txBody>
-      </p:sp>
-      <p:sp>
-        <p:nvSpPr>
-          <p:cNvPr id="15" name="Text 13"/>
-          <p:cNvSpPr txBox="1"/>
-          <p:nvPr/>
-        </p:nvSpPr>
-        <p:spPr>
-          <a:xfrm>
-            <a:off x="1325880" y="5458968"/>
-            <a:ext cx="4663440" cy="320040"/>
-          </a:xfrm>
-          <a:prstGeom prst="rect">
-            <a:avLst/>
-          </a:prstGeom>
-          <a:noFill/>
-          <a:ln/>
-        </p:spPr>
-        <p:txBody>
-          <a:bodyPr wrap="square" lIns="0" tIns="0" rIns="0" bIns="0" rtlCol="0" anchor="t"/>
-          <a:lstStyle/>
-          <a:p>
-            <a:pPr indent="0" marL="0">
-              <a:buNone/>
-            </a:pPr>
-            <a:r>
-              <a:rPr lang="en-US" sz="1400" dirty="0">
-                <a:solidFill>
-                  <a:schemeClr val="accent3"/>
-                </a:solidFill>
-              </a:rPr>
-              <a:t>Ind minus masse ud</a:t>
-            </a:r>
-            <a:endParaRPr lang="en-US" sz="1400" dirty="0"/>
-          </a:p>
-        </p:txBody>
-      </p:sp>
-      <p:sp>
-        <p:nvSpPr>
-          <p:cNvPr id="16" name="Text 14"/>
-          <p:cNvSpPr txBox="1"/>
-          <p:nvPr/>
-        </p:nvSpPr>
-        <p:spPr>
-          <a:xfrm>
-            <a:off x="6172200" y="2331720"/>
-            <a:ext cx="548640" cy="457200"/>
-          </a:xfrm>
-          <a:prstGeom prst="rect">
-            <a:avLst/>
-          </a:prstGeom>
-          <a:noFill/>
-          <a:ln/>
-        </p:spPr>
-        <p:txBody>
-          <a:bodyPr wrap="square" lIns="0" tIns="0" rIns="0" bIns="0" rtlCol="0" anchor="t"/>
-          <a:lstStyle/>
-          <a:p>
-            <a:pPr indent="0" marL="0">
-              <a:buNone/>
-            </a:pPr>
-            <a:r>
-              <a:rPr lang="en-US" sz="2600" b="1" dirty="0">
-                <a:solidFill>
-                  <a:schemeClr val="accent1"/>
-                </a:solidFill>
-              </a:rPr>
-              <a:t>5</a:t>
-            </a:r>
-            <a:endParaRPr lang="en-US" sz="2600" dirty="0"/>
-          </a:p>
-        </p:txBody>
-      </p:sp>
-      <p:sp>
-        <p:nvSpPr>
           <p:cNvPr id="17" name="Text 15"/>
-          <p:cNvSpPr txBox="1"/>
-          <p:nvPr/>
-        </p:nvSpPr>
-        <p:spPr>
-          <a:xfrm>
-            <a:off x="6812280" y="2350008"/>
-            <a:ext cx="4663440" cy="411480"/>
-          </a:xfrm>
-          <a:prstGeom prst="rect">
-            <a:avLst/>
-          </a:prstGeom>
-          <a:noFill/>
-          <a:ln/>
-        </p:spPr>
-        <p:txBody>
-          <a:bodyPr wrap="square" lIns="0" tIns="0" rIns="0" bIns="0" rtlCol="0" anchor="t"/>
-          <a:lstStyle/>
-          <a:p>
-            <a:pPr indent="0" marL="0">
-              <a:buNone/>
-            </a:pPr>
-            <a:r>
-              <a:rPr lang="en-US" sz="2400" b="1" dirty="0">
-                <a:solidFill>
-                  <a:schemeClr val="bg1"/>
-                </a:solidFill>
-              </a:rPr>
-              <a:t>Pr. time</a:t>
-            </a:r>
-            <a:endParaRPr lang="en-US" sz="2400" dirty="0"/>
-          </a:p>
-        </p:txBody>
-      </p:sp>
-      <p:sp>
-        <p:nvSpPr>
-          <p:cNvPr id="18" name="Text 16"/>
-          <p:cNvSpPr txBox="1"/>
-          <p:nvPr/>
-        </p:nvSpPr>
-        <p:spPr>
-          <a:xfrm>
-            <a:off x="6812280" y="2770632"/>
-            <a:ext cx="4663440" cy="320040"/>
-          </a:xfrm>
-          <a:prstGeom prst="rect">
-            <a:avLst/>
-          </a:prstGeom>
-          <a:noFill/>
-          <a:ln/>
-        </p:spPr>
-        <p:txBody>
-          <a:bodyPr wrap="square" lIns="0" tIns="0" rIns="0" bIns="0" rtlCol="0" anchor="t"/>
-          <a:lstStyle/>
-          <a:p>
-            <a:pPr indent="0" marL="0">
-              <a:buNone/>
-            </a:pPr>
-            <a:r>
-              <a:rPr lang="en-US" sz="1400" dirty="0">
-                <a:solidFill>
-                  <a:schemeClr val="accent3"/>
-                </a:solidFill>
-              </a:rPr>
-              <a:t>Vand delt med timer</a:t>
-            </a:r>
-            <a:endParaRPr lang="en-US" sz="1400" dirty="0"/>
-          </a:p>
-        </p:txBody>
-      </p:sp>
-      <p:sp>
-        <p:nvSpPr>
-          <p:cNvPr id="19" name="Text 17"/>
-          <p:cNvSpPr txBox="1"/>
-          <p:nvPr/>
-        </p:nvSpPr>
-        <p:spPr>
-          <a:xfrm>
-            <a:off x="6172200" y="3227832"/>
-            <a:ext cx="548640" cy="457200"/>
-          </a:xfrm>
-          <a:prstGeom prst="rect">
-            <a:avLst/>
-          </a:prstGeom>
-          <a:noFill/>
-          <a:ln/>
-        </p:spPr>
-        <p:txBody>
-          <a:bodyPr wrap="square" lIns="0" tIns="0" rIns="0" bIns="0" rtlCol="0" anchor="t"/>
-          <a:lstStyle/>
-          <a:p>
-            <a:pPr indent="0" marL="0">
-              <a:buNone/>
-            </a:pPr>
-            <a:r>
-              <a:rPr lang="en-US" sz="2600" b="1" dirty="0">
-                <a:solidFill>
-                  <a:schemeClr val="accent1"/>
-                </a:solidFill>
-              </a:rPr>
-              <a:t>6</a:t>
-            </a:r>
-            <a:endParaRPr lang="en-US" sz="2600" dirty="0"/>
-          </a:p>
-        </p:txBody>
-      </p:sp>
-      <p:sp>
-        <p:nvSpPr>
-          <p:cNvPr id="20" name="Text 18"/>
-          <p:cNvSpPr txBox="1"/>
-          <p:nvPr/>
-        </p:nvSpPr>
-        <p:spPr>
-          <a:xfrm>
-            <a:off x="6812280" y="3246120"/>
-            <a:ext cx="4663440" cy="411480"/>
-          </a:xfrm>
-          <a:prstGeom prst="rect">
-            <a:avLst/>
-          </a:prstGeom>
-          <a:noFill/>
-          <a:ln/>
-        </p:spPr>
-        <p:txBody>
-          <a:bodyPr wrap="square" lIns="0" tIns="0" rIns="0" bIns="0" rtlCol="0" anchor="t"/>
-          <a:lstStyle/>
-          <a:p>
-            <a:pPr indent="0" marL="0">
-              <a:buNone/>
-            </a:pPr>
-            <a:r>
-              <a:rPr lang="en-US" sz="2400" b="1" dirty="0">
-                <a:solidFill>
-                  <a:schemeClr val="bg1"/>
-                </a:solidFill>
-              </a:rPr>
-              <a:t>Tørstof ved slut</a:t>
-            </a:r>
-            <a:endParaRPr lang="en-US" sz="2400" dirty="0"/>
-          </a:p>
-        </p:txBody>
-      </p:sp>
-      <p:sp>
-        <p:nvSpPr>
-          <p:cNvPr id="21" name="Text 19"/>
-          <p:cNvSpPr txBox="1"/>
-          <p:nvPr/>
-        </p:nvSpPr>
-        <p:spPr>
-          <a:xfrm>
-            <a:off x="6812280" y="3666744"/>
-            <a:ext cx="4663440" cy="320040"/>
-          </a:xfrm>
-          <a:prstGeom prst="rect">
-            <a:avLst/>
-          </a:prstGeom>
-          <a:noFill/>
-          <a:ln/>
-        </p:spPr>
-        <p:txBody>
-          <a:bodyPr wrap="square" lIns="0" tIns="0" rIns="0" bIns="0" rtlCol="0" anchor="t"/>
-          <a:lstStyle/>
-          <a:p>
-            <a:pPr indent="0" marL="0">
-              <a:buNone/>
-            </a:pPr>
-            <a:r>
-              <a:rPr lang="en-US" sz="1400" dirty="0">
-                <a:solidFill>
-                  <a:schemeClr val="accent3"/>
-                </a:solidFill>
-              </a:rPr>
-              <a:t>Tørstof delt med masse ud</a:t>
-            </a:r>
-            <a:endParaRPr lang="en-US" sz="1400" dirty="0"/>
-          </a:p>
-        </p:txBody>
-      </p:sp>
-      <p:sp>
-        <p:nvSpPr>
-          <p:cNvPr id="22" name="Text 20"/>
-          <p:cNvSpPr txBox="1"/>
-          <p:nvPr/>
-        </p:nvSpPr>
-        <p:spPr>
-          <a:xfrm>
-            <a:off x="6172200" y="4123944"/>
-            <a:ext cx="548640" cy="457200"/>
-          </a:xfrm>
-          <a:prstGeom prst="rect">
-            <a:avLst/>
-          </a:prstGeom>
-          <a:noFill/>
-          <a:ln/>
-        </p:spPr>
-        <p:txBody>
-          <a:bodyPr wrap="square" lIns="0" tIns="0" rIns="0" bIns="0" rtlCol="0" anchor="t"/>
-          <a:lstStyle/>
-          <a:p>
-            <a:pPr indent="0" marL="0">
-              <a:buNone/>
-            </a:pPr>
-            <a:r>
-              <a:rPr lang="en-US" sz="2600" b="1" dirty="0">
-                <a:solidFill>
-                  <a:schemeClr val="accent1"/>
-                </a:solidFill>
-              </a:rPr>
-              <a:t>7</a:t>
-            </a:r>
-            <a:endParaRPr lang="en-US" sz="2600" dirty="0"/>
-          </a:p>
-        </p:txBody>
-      </p:sp>
-      <p:sp>
-        <p:nvSpPr>
-          <p:cNvPr id="23" name="Text 21"/>
-          <p:cNvSpPr txBox="1"/>
-          <p:nvPr/>
-        </p:nvSpPr>
-        <p:spPr>
-          <a:xfrm>
-            <a:off x="6812280" y="4142232"/>
-            <a:ext cx="4663440" cy="411480"/>
-          </a:xfrm>
-          <a:prstGeom prst="rect">
-            <a:avLst/>
-          </a:prstGeom>
-          <a:noFill/>
-          <a:ln/>
-        </p:spPr>
-        <p:txBody>
-          <a:bodyPr wrap="square" lIns="0" tIns="0" rIns="0" bIns="0" rtlCol="0" anchor="t"/>
-          <a:lstStyle/>
-          <a:p>
-            <a:pPr indent="0" marL="0">
-              <a:buNone/>
-            </a:pPr>
-            <a:r>
-              <a:rPr lang="en-US" sz="2400" b="1" dirty="0">
-                <a:solidFill>
-                  <a:schemeClr val="bg1"/>
-                </a:solidFill>
-              </a:rPr>
-              <a:t>1.500 kg mere</a:t>
-            </a:r>
-            <a:endParaRPr lang="en-US" sz="2400" dirty="0"/>
-          </a:p>
-        </p:txBody>
-      </p:sp>
-      <p:sp>
-        <p:nvSpPr>
-          <p:cNvPr id="24" name="Text 22"/>
-          <p:cNvSpPr txBox="1"/>
-          <p:nvPr/>
-        </p:nvSpPr>
-        <p:spPr>
-          <a:xfrm>
-            <a:off x="6812280" y="4562856"/>
-            <a:ext cx="4663440" cy="320040"/>
-          </a:xfrm>
-          <a:prstGeom prst="rect">
-            <a:avLst/>
-          </a:prstGeom>
-          <a:noFill/>
-          <a:ln/>
-        </p:spPr>
-        <p:txBody>
-          <a:bodyPr wrap="square" lIns="0" tIns="0" rIns="0" bIns="0" rtlCol="0" anchor="t"/>
-          <a:lstStyle/>
-          <a:p>
-            <a:pPr indent="0" marL="0">
-              <a:buNone/>
-            </a:pPr>
-            <a:r>
-              <a:rPr lang="en-US" sz="1400" dirty="0">
-                <a:solidFill>
-                  <a:schemeClr val="accent3"/>
-                </a:solidFill>
-              </a:rPr>
-              <a:t>Lås inputcellen med dollartegn</a:t>
-            </a:r>
-            <a:endParaRPr lang="en-US" sz="1400" dirty="0"/>
-          </a:p>
-        </p:txBody>
-      </p:sp>
-      <p:sp>
-        <p:nvSpPr>
-          <p:cNvPr id="25" name="Text 23"/>
-          <p:cNvSpPr txBox="1"/>
-          <p:nvPr/>
-        </p:nvSpPr>
-        <p:spPr>
-          <a:xfrm>
-            <a:off x="6172200" y="5020056"/>
-            <a:ext cx="548640" cy="457200"/>
-          </a:xfrm>
-          <a:prstGeom prst="rect">
-            <a:avLst/>
-          </a:prstGeom>
-          <a:noFill/>
-          <a:ln/>
-        </p:spPr>
-        <p:txBody>
-          <a:bodyPr wrap="square" lIns="0" tIns="0" rIns="0" bIns="0" rtlCol="0" anchor="t"/>
-          <a:lstStyle/>
-          <a:p>
-            <a:pPr indent="0" marL="0">
-              <a:buNone/>
-            </a:pPr>
-            <a:r>
-              <a:rPr lang="en-US" sz="2600" b="1" dirty="0">
-                <a:solidFill>
-                  <a:schemeClr val="accent1"/>
-                </a:solidFill>
-              </a:rPr>
-              <a:t>8</a:t>
-            </a:r>
-            <a:endParaRPr lang="en-US" sz="2600" dirty="0"/>
-          </a:p>
-        </p:txBody>
-      </p:sp>
-      <p:sp>
-        <p:nvSpPr>
-          <p:cNvPr id="26" name="Text 24"/>
-          <p:cNvSpPr txBox="1"/>
-          <p:nvPr/>
-        </p:nvSpPr>
-        <p:spPr>
-          <a:xfrm>
-            <a:off x="6812280" y="5038344"/>
-            <a:ext cx="4663440" cy="411480"/>
-          </a:xfrm>
-          <a:prstGeom prst="rect">
-            <a:avLst/>
-          </a:prstGeom>
-          <a:noFill/>
-          <a:ln/>
-        </p:spPr>
-        <p:txBody>
-          <a:bodyPr wrap="square" lIns="0" tIns="0" rIns="0" bIns="0" rtlCol="0" anchor="t"/>
-          <a:lstStyle/>
-          <a:p>
-            <a:pPr indent="0" marL="0">
-              <a:buNone/>
-            </a:pPr>
-            <a:r>
-              <a:rPr lang="en-US" sz="2400" b="1" dirty="0">
-                <a:solidFill>
-                  <a:schemeClr val="bg1"/>
-                </a:solidFill>
-              </a:rPr>
-              <a:t>Brovægt</a:t>
-            </a:r>
-            <a:endParaRPr lang="en-US" sz="2400" dirty="0"/>
-          </a:p>
-        </p:txBody>
-      </p:sp>
-      <p:sp>
-        <p:nvSpPr>
-          <p:cNvPr id="27" name="Text 25"/>
-          <p:cNvSpPr txBox="1"/>
-          <p:nvPr/>
-        </p:nvSpPr>
-        <p:spPr>
-          <a:xfrm>
-            <a:off x="6812280" y="5458968"/>
-            <a:ext cx="4663440" cy="320040"/>
-          </a:xfrm>
-          <a:prstGeom prst="rect">
-            <a:avLst/>
-          </a:prstGeom>
-          <a:noFill/>
-          <a:ln/>
-        </p:spPr>
-        <p:txBody>
-          <a:bodyPr wrap="square" lIns="0" tIns="0" rIns="0" bIns="0" rtlCol="0" anchor="t"/>
-          <a:lstStyle/>
-          <a:p>
-            <a:pPr indent="0" marL="0">
-              <a:buNone/>
-            </a:pPr>
-            <a:r>
-              <a:rPr lang="en-US" sz="1400" dirty="0">
-                <a:solidFill>
-                  <a:schemeClr val="accent3"/>
-                </a:solidFill>
-              </a:rPr>
-              <a:t>Går balancen op? HVIS og ABS</a:t>
-            </a:r>
-            <a:endParaRPr lang="en-US" sz="1400" dirty="0"/>
-          </a:p>
-        </p:txBody>
-      </p:sp>
-      <p:sp>
-        <p:nvSpPr>
-          <p:cNvPr id="28" name="Text 26"/>
           <p:cNvSpPr txBox="1"/>
           <p:nvPr/>
         </p:nvSpPr>
@@ -20262,7 +19857,7 @@
                   <a:schemeClr val="accent3"/>
                 </a:solidFill>
               </a:rPr>
-              <a:t>Fanen Opgave i datasættet. Formlerne står på opgavearket. T-07 er tallene fra Opgave 13, så I har facit.</a:t>
+              <a:t>De tre spørgsmål fra Opgave 13 i fanen Opgave. Prompterne står på opgavearket.</a:t>
             </a:r>
             <a:endParaRPr lang="en-US" sz="1200" dirty="0"/>
           </a:p>
@@ -20431,7 +20026,7 @@
                   <a:schemeClr val="bg1"/>
                 </a:solidFill>
               </a:rPr>
-              <a:t>. Byg massebalancen som formler for alle 14 batches, og tjek T-07 mod jeres udregning fra Opgave 13.</a:t>
+              <a:t>, og lad ChatGPT i Excel skrive de tre formler. Tjek T-07 mod jeres udregning fra Opgave 13.</a:t>
             </a:r>
             <a:endParaRPr lang="en-US" sz="2600" dirty="0"/>
           </a:p>
@@ -20467,7 +20062,7 @@
                   <a:schemeClr val="accent3"/>
                 </a:solidFill>
               </a:rPr>
-              <a:t>AI må forklare og rette. I skriver selv formlerne ind.</a:t>
+              <a:t>Tjek tallet, før I tror på det.</a:t>
             </a:r>
             <a:endParaRPr lang="en-US" sz="2000" dirty="0"/>
           </a:p>
@@ -20562,12 +20157,12 @@
               <a:buNone/>
             </a:pPr>
             <a:r>
-              <a:rPr lang="en-US" sz="6000" b="1" dirty="0">
+              <a:rPr lang="en-US" sz="6600" b="1" dirty="0">
                 <a:solidFill>
                   <a:schemeClr val="bg1"/>
                 </a:solidFill>
               </a:rPr>
-              <a:t>Byg det selv én gang. </a:t>
+              <a:t>Lad AI skrive formlen. </a:t>
             </a:r>
             <a:pPr indent="0" marL="0">
               <a:lnSpc>
@@ -20576,14 +20171,14 @@
               <a:buNone/>
             </a:pPr>
             <a:r>
-              <a:rPr lang="en-US" sz="6000" b="1" dirty="0">
+              <a:rPr lang="en-US" sz="6600" b="1" dirty="0">
                 <a:solidFill>
                   <a:schemeClr val="accent1"/>
                 </a:solidFill>
               </a:rPr>
-              <a:t>Så ved du, hvad AI skal lave.</a:t>
-            </a:r>
-            <a:endParaRPr lang="en-US" sz="6000" dirty="0"/>
+              <a:t>Tjek tallet selv.</a:t>
+            </a:r>
+            <a:endParaRPr lang="en-US" sz="6600" dirty="0"/>
           </a:p>
         </p:txBody>
       </p:sp>

</xml_diff>

<commit_message>
Procesteknolog: ét ark med overblik og opgaver til ChatGPT i Excel
Tre prompts til overblik, en sparringsprompt og tre opgaver, hvor ChatGPT
spørger uden at give facit. Erstatter promptkort og opgaveark for procesteknolog.
Materialelisten er nu pr. uddannelse.

Co-Authored-By: Claude Fable 5.1 <noreply@anthropic.com>
Claude-Session: https://claude.ai/code/session_015YJpkwAMXruZRjbkCwcfYy
</commit_message>
<xml_diff>
--- a/private/proces/praesentation.pptx
+++ b/private/proces/praesentation.pptx
@@ -160,7 +160,7 @@
   <p:extLst>
     <p:ext uri="{521415D9-36F7-43E2-AB2F-B90AF26B5E84}">
       <p14:sectionLst xmlns:p14="http://schemas.microsoft.com/office/powerpoint/2010/main">
-        <p14:section name="Åbning" id="{017ba0d1-656e-1d29-a133-a7e0006808df}">
+        <p14:section name="Åbning" id="{b24dd4a3-db13-4744-17c7-346a7239e6ea}">
           <p14:sldIdLst>
             <p14:sldId id="256"/>
             <p14:sldId id="257"/>
@@ -170,7 +170,7 @@
             <p14:sldId id="261"/>
           </p14:sldIdLst>
         </p14:section>
-        <p14:section name="Som studerende" id="{2f6c7a6d-079d-ce48-9a6e-fd8f97de239c}">
+        <p14:section name="Som studerende" id="{c66dd1a5-150d-d569-94d8-3ba9972f999b}">
           <p14:sldIdLst>
             <p14:sldId id="262"/>
             <p14:sldId id="263"/>
@@ -182,7 +182,7 @@
             <p14:sldId id="269"/>
           </p14:sldIdLst>
         </p14:section>
-        <p14:section name="Prompting" id="{c11a35e7-89c4-f79b-9d54-e976c1224dcc}">
+        <p14:section name="Prompting" id="{76e96fcd-3f3c-100f-1e0d-121a0e4586c3}">
           <p14:sldIdLst>
             <p14:sldId id="270"/>
             <p14:sldId id="271"/>
@@ -193,7 +193,7 @@
             <p14:sldId id="276"/>
           </p14:sldIdLst>
         </p14:section>
-        <p14:section name="Excel og data" id="{cca4b236-cfc9-ca0d-8246-55f7013eca91}">
+        <p14:section name="Excel og data" id="{f193a653-7796-0466-fd8d-c53383dc3563}">
           <p14:sldIdLst>
             <p14:sldId id="277"/>
             <p14:sldId id="278"/>
@@ -212,7 +212,7 @@
             <p14:sldId id="291"/>
           </p14:sldIdLst>
         </p14:section>
-        <p14:section name="AI i jobbet" id="{88d2119a-6e71-3299-3de4-d40275150d8b}">
+        <p14:section name="AI i jobbet" id="{0ac7621c-61df-d9af-cad7-739cabe9ba42}">
           <p14:sldIdLst>
             <p14:sldId id="292"/>
             <p14:sldId id="293"/>
@@ -225,7 +225,7 @@
             <p14:sldId id="300"/>
           </p14:sldIdLst>
         </p14:section>
-        <p14:section name="Vibecoding" id="{6b4b8213-4b5f-e44d-9caf-40efe0ecd097}">
+        <p14:section name="Vibecoding" id="{c9c06156-bac6-ef08-b2cf-ba2799f73371}">
           <p14:sldIdLst>
             <p14:sldId id="301"/>
             <p14:sldId id="302"/>
@@ -235,7 +235,7 @@
             <p14:sldId id="306"/>
           </p14:sldIdLst>
         </p14:section>
-        <p14:section name="Afrunding" id="{8cf99049-23d7-2a05-7672-c377dd7a9551}">
+        <p14:section name="Afrunding" id="{c9889f06-b0d1-c598-7488-430654a485dc}">
           <p14:sldIdLst>
             <p14:sldId id="307"/>
             <p14:sldId id="308"/>
@@ -3621,7 +3621,7 @@
           <a:p>
             <a:r>
               <a:rPr lang="en-US" dirty="0"/>
-              <a:t>Prompterne står fuldt ud på promptkortet i Bilag C. Kør dem i rækkefølge. Hver prompt bygger videre på den forrige.</a:t>
+              <a:t>Prompterne står fuldt ud i undervisningsplanen under live demo. Kør dem i rækkefølge. Hver prompt bygger videre på den forrige. De studerende får et andet ark med tre overbliksprompts og tre opgaver.</a:t>
             </a:r>
             <a:endParaRPr lang="en-US" dirty="0"/>
           </a:p>
@@ -4501,7 +4501,7 @@
           <a:p>
             <a:r>
               <a:rPr lang="en-US" dirty="0"/>
-              <a:t>Opgaven i Excel. Fanen Opgave har 13 batches og tre tomme kolonner, der svarer til de tre spørgsmål i Opgave 13. De studerende åbner ChatGPT i Excel fra sidepanelet, beder om formlen til række 2, sætter den ind og trækker den ned. Tjekket er, at T-07 giver 13.816 kg vand, 107,9 kg i timen og 85,5 procent tørstof med 1.500 kg mere fjernet. Det er de tal, de selv regnede i Opgave 13. Prompterne står på opgavearket.</a:t>
+              <a:t>Sådan arbejder de i hands-on. Først tilføjer de ChatGPT til Excel under Hjem og Tilføjelsesprogrammer og logger ind. Så sætter de tre prompts ind, der giver overblik over filen. Det er jobreglen, de tager svarene. Derefter sætter de sparringsprompten ind, som forbyder ChatGPT at give formler og facit, og løser tre opgaver. Det er studiereglen. Opgave 1 er de tre spørgsmål fra Opgave 13 for T-07, opgave 2 er batch T-14, der ikke bliver færdig, og opgave 3 er brovægten. Facit står i Bilag D.</a:t>
             </a:r>
             <a:endParaRPr lang="en-US" dirty="0"/>
           </a:p>
@@ -4589,7 +4589,7 @@
           <a:p>
             <a:r>
               <a:rPr lang="en-US" dirty="0"/>
-              <a:t>Hands-on. Parvis åbner de fanen Opgave og ChatGPT i Excel. Gå rundt og hjælp. Typiske problemer er login i tilføjelsen og procenter, der står som tal. Bagefter viser et par sit ark på storskærmen, tallene for T-07, og hvordan de tjekkede ChatGPT. Fejler tilføjelsen, så kør samme prompts i ChatGPT i browseren med filen uploadet.</a:t>
+              <a:t>Hands-on. Parvis. Gå rundt og hjælp. Typiske problemer er login i tilføjelsen, og at ChatGPT alligevel giver formlen. Så beder de den om at holde sig til sparringsprompten. Bagefter viser et par sit ark og tallene for T-07, og hvad ChatGPT spurgte dem om. Fejler tilføjelsen, så kør samme prompts i ChatGPT i browseren med filen uploadet.</a:t>
             </a:r>
             <a:endParaRPr lang="en-US" dirty="0"/>
           </a:p>
@@ -4677,7 +4677,7 @@
           <a:p>
             <a:r>
               <a:rPr lang="en-US" dirty="0"/>
-              <a:t>Pointen for Excel-delen. AI skriver formlen på sekunder. Den, der kender regnestykket, kan se, om tallet passer. I jobbet stiller I spørgsmålet, og AI laver regnearbejdet.</a:t>
+              <a:t>Pointen for Excel-delen. Med sparringsprompten bliver ChatGPT en underviser, der spørger, til I selv kan regne og forklare. I jobbet vender I den om og lader AI regne.</a:t>
             </a:r>
             <a:endParaRPr lang="en-US" dirty="0"/>
           </a:p>
@@ -19307,7 +19307,7 @@
                   <a:schemeClr val="accent3"/>
                 </a:solidFill>
               </a:rPr>
-              <a:t>HANDS-ON  ·  OPGAVEN I EXCEL</a:t>
+              <a:t>HANDS-ON  ·  CHATGPT I EXCEL</a:t>
             </a:r>
             <a:endParaRPr lang="en-US" sz="1200" dirty="0"/>
           </a:p>
@@ -19348,7 +19348,7 @@
                   <a:schemeClr val="bg1"/>
                 </a:solidFill>
               </a:rPr>
-              <a:t>Tre spørgsmål. </a:t>
+              <a:t>Åbn Excel. </a:t>
             </a:r>
             <a:pPr algn="l" indent="0" marL="0">
               <a:lnSpc>
@@ -19362,7 +19362,7 @@
                   <a:schemeClr val="accent1"/>
                 </a:solidFill>
               </a:rPr>
-              <a:t>ChatGPT skriver formlerne</a:t>
+              <a:t>Tilføj ChatGPT.</a:t>
             </a:r>
             <a:endParaRPr lang="en-US" sz="3400" dirty="0"/>
           </a:p>
@@ -19376,31 +19376,31 @@
         </p:nvSpPr>
         <p:spPr>
           <a:xfrm>
-            <a:off x="685800" y="2331720"/>
-            <a:ext cx="548640" cy="457200"/>
-          </a:xfrm>
-          <a:prstGeom prst="rect">
-            <a:avLst/>
-          </a:prstGeom>
-          <a:noFill/>
-          <a:ln/>
-        </p:spPr>
-        <p:txBody>
-          <a:bodyPr wrap="square" lIns="0" tIns="0" rIns="0" bIns="0" rtlCol="0" anchor="t"/>
-          <a:lstStyle/>
-          <a:p>
-            <a:pPr indent="0" marL="0">
-              <a:buNone/>
-            </a:pPr>
-            <a:r>
-              <a:rPr lang="en-US" sz="2800" b="1" dirty="0">
+            <a:off x="685800" y="2468880"/>
+            <a:ext cx="914400" cy="365760"/>
+          </a:xfrm>
+          <a:prstGeom prst="rect">
+            <a:avLst/>
+          </a:prstGeom>
+          <a:noFill/>
+          <a:ln/>
+        </p:spPr>
+        <p:txBody>
+          <a:bodyPr wrap="square" lIns="0" tIns="0" rIns="0" bIns="0" rtlCol="0" anchor="t"/>
+          <a:lstStyle/>
+          <a:p>
+            <a:pPr indent="0" marL="0">
+              <a:buNone/>
+            </a:pPr>
+            <a:r>
+              <a:rPr lang="en-US" sz="1600" b="1" dirty="0">
                 <a:solidFill>
                   <a:schemeClr val="accent1"/>
                 </a:solidFill>
               </a:rPr>
-              <a:t>1</a:t>
-            </a:r>
-            <a:endParaRPr lang="en-US" sz="2800" dirty="0"/>
+              <a:t>01</a:t>
+            </a:r>
+            <a:endParaRPr lang="en-US" sz="1600" dirty="0"/>
           </a:p>
         </p:txBody>
       </p:sp>
@@ -19412,31 +19412,31 @@
         </p:nvSpPr>
         <p:spPr>
           <a:xfrm>
-            <a:off x="1417320" y="2350008"/>
-            <a:ext cx="6583680" cy="457200"/>
-          </a:xfrm>
-          <a:prstGeom prst="rect">
-            <a:avLst/>
-          </a:prstGeom>
-          <a:noFill/>
-          <a:ln/>
-        </p:spPr>
-        <p:txBody>
-          <a:bodyPr wrap="square" lIns="0" tIns="0" rIns="0" bIns="0" rtlCol="0" anchor="t"/>
-          <a:lstStyle/>
-          <a:p>
-            <a:pPr indent="0" marL="0">
-              <a:buNone/>
-            </a:pPr>
-            <a:r>
-              <a:rPr lang="en-US" sz="2600" b="1" dirty="0">
+            <a:off x="685800" y="2880360"/>
+            <a:ext cx="3240938" cy="731520"/>
+          </a:xfrm>
+          <a:prstGeom prst="rect">
+            <a:avLst/>
+          </a:prstGeom>
+          <a:noFill/>
+          <a:ln/>
+        </p:spPr>
+        <p:txBody>
+          <a:bodyPr wrap="square" lIns="0" tIns="0" rIns="0" bIns="0" rtlCol="0" anchor="t"/>
+          <a:lstStyle/>
+          <a:p>
+            <a:pPr indent="0" marL="0">
+              <a:buNone/>
+            </a:pPr>
+            <a:r>
+              <a:rPr lang="en-US" sz="3400" b="1" dirty="0">
                 <a:solidFill>
                   <a:schemeClr val="bg1"/>
                 </a:solidFill>
               </a:rPr>
-              <a:t>Vand fjernet i kg</a:t>
-            </a:r>
-            <a:endParaRPr lang="en-US" sz="2600" dirty="0"/>
+              <a:t>Kom i gang</a:t>
+            </a:r>
+            <a:endParaRPr lang="en-US" sz="3400" dirty="0"/>
           </a:p>
         </p:txBody>
       </p:sp>
@@ -19448,31 +19448,31 @@
         </p:nvSpPr>
         <p:spPr>
           <a:xfrm>
-            <a:off x="1417320" y="2807208"/>
-            <a:ext cx="6583680" cy="320040"/>
-          </a:xfrm>
-          <a:prstGeom prst="rect">
-            <a:avLst/>
-          </a:prstGeom>
-          <a:noFill/>
-          <a:ln/>
-        </p:spPr>
-        <p:txBody>
-          <a:bodyPr wrap="square" lIns="0" tIns="0" rIns="0" bIns="0" rtlCol="0" anchor="t"/>
-          <a:lstStyle/>
-          <a:p>
-            <a:pPr indent="0" marL="0">
-              <a:buNone/>
-            </a:pPr>
-            <a:r>
-              <a:rPr lang="en-US" sz="1500" dirty="0">
+            <a:off x="685800" y="3749040"/>
+            <a:ext cx="3149498" cy="1463040"/>
+          </a:xfrm>
+          <a:prstGeom prst="rect">
+            <a:avLst/>
+          </a:prstGeom>
+          <a:noFill/>
+          <a:ln/>
+        </p:spPr>
+        <p:txBody>
+          <a:bodyPr wrap="square" lIns="0" tIns="0" rIns="0" bIns="0" rtlCol="0" anchor="t"/>
+          <a:lstStyle/>
+          <a:p>
+            <a:pPr indent="0" marL="0">
+              <a:buNone/>
+            </a:pPr>
+            <a:r>
+              <a:rPr lang="en-US" sz="1700" dirty="0">
                 <a:solidFill>
                   <a:schemeClr val="accent3"/>
                 </a:solidFill>
               </a:rPr>
-              <a:t>T-07 giver 13.816 kg</a:t>
-            </a:r>
-            <a:endParaRPr lang="en-US" sz="1500" dirty="0"/>
+              <a:t>Hjem, Tilføjelsesprogrammer, ChatGPT. Log ind, og ChatGPT læser hele filen i sidepanelet.</a:t>
+            </a:r>
+            <a:endParaRPr lang="en-US" sz="1700" dirty="0"/>
           </a:p>
         </p:txBody>
       </p:sp>
@@ -19484,31 +19484,31 @@
         </p:nvSpPr>
         <p:spPr>
           <a:xfrm>
-            <a:off x="685800" y="3337560"/>
-            <a:ext cx="548640" cy="457200"/>
-          </a:xfrm>
-          <a:prstGeom prst="rect">
-            <a:avLst/>
-          </a:prstGeom>
-          <a:noFill/>
-          <a:ln/>
-        </p:spPr>
-        <p:txBody>
-          <a:bodyPr wrap="square" lIns="0" tIns="0" rIns="0" bIns="0" rtlCol="0" anchor="t"/>
-          <a:lstStyle/>
-          <a:p>
-            <a:pPr indent="0" marL="0">
-              <a:buNone/>
-            </a:pPr>
-            <a:r>
-              <a:rPr lang="en-US" sz="2800" b="1" dirty="0">
+            <a:off x="4292498" y="2468880"/>
+            <a:ext cx="914400" cy="365760"/>
+          </a:xfrm>
+          <a:prstGeom prst="rect">
+            <a:avLst/>
+          </a:prstGeom>
+          <a:noFill/>
+          <a:ln/>
+        </p:spPr>
+        <p:txBody>
+          <a:bodyPr wrap="square" lIns="0" tIns="0" rIns="0" bIns="0" rtlCol="0" anchor="t"/>
+          <a:lstStyle/>
+          <a:p>
+            <a:pPr indent="0" marL="0">
+              <a:buNone/>
+            </a:pPr>
+            <a:r>
+              <a:rPr lang="en-US" sz="1600" b="1" dirty="0">
                 <a:solidFill>
                   <a:schemeClr val="accent1"/>
                 </a:solidFill>
               </a:rPr>
-              <a:t>2</a:t>
-            </a:r>
-            <a:endParaRPr lang="en-US" sz="2800" dirty="0"/>
+              <a:t>02</a:t>
+            </a:r>
+            <a:endParaRPr lang="en-US" sz="1600" dirty="0"/>
           </a:p>
         </p:txBody>
       </p:sp>
@@ -19520,31 +19520,31 @@
         </p:nvSpPr>
         <p:spPr>
           <a:xfrm>
-            <a:off x="1417320" y="3355848"/>
-            <a:ext cx="6583680" cy="457200"/>
-          </a:xfrm>
-          <a:prstGeom prst="rect">
-            <a:avLst/>
-          </a:prstGeom>
-          <a:noFill/>
-          <a:ln/>
-        </p:spPr>
-        <p:txBody>
-          <a:bodyPr wrap="square" lIns="0" tIns="0" rIns="0" bIns="0" rtlCol="0" anchor="t"/>
-          <a:lstStyle/>
-          <a:p>
-            <a:pPr indent="0" marL="0">
-              <a:buNone/>
-            </a:pPr>
-            <a:r>
-              <a:rPr lang="en-US" sz="2600" b="1" dirty="0">
+            <a:off x="4292498" y="2880360"/>
+            <a:ext cx="3240938" cy="731520"/>
+          </a:xfrm>
+          <a:prstGeom prst="rect">
+            <a:avLst/>
+          </a:prstGeom>
+          <a:noFill/>
+          <a:ln/>
+        </p:spPr>
+        <p:txBody>
+          <a:bodyPr wrap="square" lIns="0" tIns="0" rIns="0" bIns="0" rtlCol="0" anchor="t"/>
+          <a:lstStyle/>
+          <a:p>
+            <a:pPr indent="0" marL="0">
+              <a:buNone/>
+            </a:pPr>
+            <a:r>
+              <a:rPr lang="en-US" sz="3400" b="1" dirty="0">
                 <a:solidFill>
                   <a:schemeClr val="bg1"/>
                 </a:solidFill>
               </a:rPr>
-              <a:t>Vand pr. time</a:t>
-            </a:r>
-            <a:endParaRPr lang="en-US" sz="2600" dirty="0"/>
+              <a:t>Få overblik</a:t>
+            </a:r>
+            <a:endParaRPr lang="en-US" sz="3400" dirty="0"/>
           </a:p>
         </p:txBody>
       </p:sp>
@@ -19556,31 +19556,31 @@
         </p:nvSpPr>
         <p:spPr>
           <a:xfrm>
-            <a:off x="1417320" y="3813048"/>
-            <a:ext cx="6583680" cy="320040"/>
-          </a:xfrm>
-          <a:prstGeom prst="rect">
-            <a:avLst/>
-          </a:prstGeom>
-          <a:noFill/>
-          <a:ln/>
-        </p:spPr>
-        <p:txBody>
-          <a:bodyPr wrap="square" lIns="0" tIns="0" rIns="0" bIns="0" rtlCol="0" anchor="t"/>
-          <a:lstStyle/>
-          <a:p>
-            <a:pPr indent="0" marL="0">
-              <a:buNone/>
-            </a:pPr>
-            <a:r>
-              <a:rPr lang="en-US" sz="1500" dirty="0">
+            <a:off x="4292498" y="3749040"/>
+            <a:ext cx="3149498" cy="1463040"/>
+          </a:xfrm>
+          <a:prstGeom prst="rect">
+            <a:avLst/>
+          </a:prstGeom>
+          <a:noFill/>
+          <a:ln/>
+        </p:spPr>
+        <p:txBody>
+          <a:bodyPr wrap="square" lIns="0" tIns="0" rIns="0" bIns="0" rtlCol="0" anchor="t"/>
+          <a:lstStyle/>
+          <a:p>
+            <a:pPr indent="0" marL="0">
+              <a:buNone/>
+            </a:pPr>
+            <a:r>
+              <a:rPr lang="en-US" sz="1700" dirty="0">
                 <a:solidFill>
                   <a:schemeClr val="accent3"/>
                 </a:solidFill>
               </a:rPr>
-              <a:t>T-07 giver 107,9 kg</a:t>
-            </a:r>
-            <a:endParaRPr lang="en-US" sz="1500" dirty="0"/>
+              <a:t>Tre prompts, som I sætter ind, som de står. Her gælder jobreglen. Tag svarene.</a:t>
+            </a:r>
+            <a:endParaRPr lang="en-US" sz="1700" dirty="0"/>
           </a:p>
         </p:txBody>
       </p:sp>
@@ -19592,31 +19592,31 @@
         </p:nvSpPr>
         <p:spPr>
           <a:xfrm>
-            <a:off x="685800" y="4343400"/>
-            <a:ext cx="548640" cy="457200"/>
-          </a:xfrm>
-          <a:prstGeom prst="rect">
-            <a:avLst/>
-          </a:prstGeom>
-          <a:noFill/>
-          <a:ln/>
-        </p:spPr>
-        <p:txBody>
-          <a:bodyPr wrap="square" lIns="0" tIns="0" rIns="0" bIns="0" rtlCol="0" anchor="t"/>
-          <a:lstStyle/>
-          <a:p>
-            <a:pPr indent="0" marL="0">
-              <a:buNone/>
-            </a:pPr>
-            <a:r>
-              <a:rPr lang="en-US" sz="2800" b="1" dirty="0">
+            <a:off x="7899197" y="2468880"/>
+            <a:ext cx="914400" cy="365760"/>
+          </a:xfrm>
+          <a:prstGeom prst="rect">
+            <a:avLst/>
+          </a:prstGeom>
+          <a:noFill/>
+          <a:ln/>
+        </p:spPr>
+        <p:txBody>
+          <a:bodyPr wrap="square" lIns="0" tIns="0" rIns="0" bIns="0" rtlCol="0" anchor="t"/>
+          <a:lstStyle/>
+          <a:p>
+            <a:pPr indent="0" marL="0">
+              <a:buNone/>
+            </a:pPr>
+            <a:r>
+              <a:rPr lang="en-US" sz="1600" b="1" dirty="0">
                 <a:solidFill>
                   <a:schemeClr val="accent1"/>
                 </a:solidFill>
               </a:rPr>
-              <a:t>3</a:t>
-            </a:r>
-            <a:endParaRPr lang="en-US" sz="2800" dirty="0"/>
+              <a:t>03</a:t>
+            </a:r>
+            <a:endParaRPr lang="en-US" sz="1600" dirty="0"/>
           </a:p>
         </p:txBody>
       </p:sp>
@@ -19628,31 +19628,31 @@
         </p:nvSpPr>
         <p:spPr>
           <a:xfrm>
-            <a:off x="1417320" y="4361688"/>
-            <a:ext cx="6583680" cy="457200"/>
-          </a:xfrm>
-          <a:prstGeom prst="rect">
-            <a:avLst/>
-          </a:prstGeom>
-          <a:noFill/>
-          <a:ln/>
-        </p:spPr>
-        <p:txBody>
-          <a:bodyPr wrap="square" lIns="0" tIns="0" rIns="0" bIns="0" rtlCol="0" anchor="t"/>
-          <a:lstStyle/>
-          <a:p>
-            <a:pPr indent="0" marL="0">
-              <a:buNone/>
-            </a:pPr>
-            <a:r>
-              <a:rPr lang="en-US" sz="2600" b="1" dirty="0">
+            <a:off x="7899197" y="2880360"/>
+            <a:ext cx="3240938" cy="731520"/>
+          </a:xfrm>
+          <a:prstGeom prst="rect">
+            <a:avLst/>
+          </a:prstGeom>
+          <a:noFill/>
+          <a:ln/>
+        </p:spPr>
+        <p:txBody>
+          <a:bodyPr wrap="square" lIns="0" tIns="0" rIns="0" bIns="0" rtlCol="0" anchor="t"/>
+          <a:lstStyle/>
+          <a:p>
+            <a:pPr indent="0" marL="0">
+              <a:buNone/>
+            </a:pPr>
+            <a:r>
+              <a:rPr lang="en-US" sz="3400" b="1" dirty="0">
                 <a:solidFill>
                   <a:schemeClr val="bg1"/>
                 </a:solidFill>
               </a:rPr>
-              <a:t>Tørstof med ekstra vand fjernet</a:t>
-            </a:r>
-            <a:endParaRPr lang="en-US" sz="2600" dirty="0"/>
+              <a:t>Løs opgaverne</a:t>
+            </a:r>
+            <a:endParaRPr lang="en-US" sz="3400" dirty="0"/>
           </a:p>
         </p:txBody>
       </p:sp>
@@ -19664,172 +19664,37 @@
         </p:nvSpPr>
         <p:spPr>
           <a:xfrm>
-            <a:off x="1417320" y="4818888"/>
-            <a:ext cx="6583680" cy="320040"/>
-          </a:xfrm>
-          <a:prstGeom prst="rect">
-            <a:avLst/>
-          </a:prstGeom>
-          <a:noFill/>
-          <a:ln/>
-        </p:spPr>
-        <p:txBody>
-          <a:bodyPr wrap="square" lIns="0" tIns="0" rIns="0" bIns="0" rtlCol="0" anchor="t"/>
-          <a:lstStyle/>
-          <a:p>
-            <a:pPr indent="0" marL="0">
-              <a:buNone/>
-            </a:pPr>
-            <a:r>
-              <a:rPr lang="en-US" sz="1500" dirty="0">
+            <a:off x="7899197" y="3749040"/>
+            <a:ext cx="3149498" cy="1463040"/>
+          </a:xfrm>
+          <a:prstGeom prst="rect">
+            <a:avLst/>
+          </a:prstGeom>
+          <a:noFill/>
+          <a:ln/>
+        </p:spPr>
+        <p:txBody>
+          <a:bodyPr wrap="square" lIns="0" tIns="0" rIns="0" bIns="0" rtlCol="0" anchor="t"/>
+          <a:lstStyle/>
+          <a:p>
+            <a:pPr indent="0" marL="0">
+              <a:buNone/>
+            </a:pPr>
+            <a:r>
+              <a:rPr lang="en-US" sz="1700" dirty="0">
                 <a:solidFill>
                   <a:schemeClr val="accent3"/>
                 </a:solidFill>
               </a:rPr>
-              <a:t>T-07 giver 85,5 %</a:t>
-            </a:r>
-            <a:endParaRPr lang="en-US" sz="1500" dirty="0"/>
-          </a:p>
-        </p:txBody>
-      </p:sp>
-      <p:sp>
-        <p:nvSpPr>
-          <p:cNvPr id="13" name="Shape 11"/>
-          <p:cNvSpPr/>
-          <p:nvPr/>
-        </p:nvSpPr>
-        <p:spPr>
-          <a:xfrm>
-            <a:off x="8229600" y="2286000"/>
-            <a:ext cx="3273552" cy="3017520"/>
-          </a:xfrm>
-          <a:prstGeom prst="roundRect">
-            <a:avLst>
-              <a:gd name="adj" fmla="val 3636"/>
-            </a:avLst>
-          </a:prstGeom>
-          <a:solidFill>
-            <a:schemeClr val="accent6"/>
-          </a:solidFill>
-          <a:ln w="12700">
-            <a:solidFill>
-              <a:schemeClr val="accent6"/>
-            </a:solidFill>
-            <a:prstDash val="solid"/>
-          </a:ln>
-        </p:spPr>
-      </p:sp>
-      <p:sp>
-        <p:nvSpPr>
-          <p:cNvPr id="14" name="Text 12"/>
-          <p:cNvSpPr txBox="1"/>
-          <p:nvPr/>
-        </p:nvSpPr>
-        <p:spPr>
-          <a:xfrm>
-            <a:off x="8503920" y="2560320"/>
-            <a:ext cx="2743200" cy="274320"/>
-          </a:xfrm>
-          <a:prstGeom prst="rect">
-            <a:avLst/>
-          </a:prstGeom>
-          <a:noFill/>
-          <a:ln/>
-        </p:spPr>
-        <p:txBody>
-          <a:bodyPr wrap="square" lIns="0" tIns="0" rIns="0" bIns="0" rtlCol="0" anchor="t"/>
-          <a:lstStyle/>
-          <a:p>
-            <a:pPr indent="0" marL="0">
-              <a:buNone/>
-            </a:pPr>
-            <a:r>
-              <a:rPr lang="en-US" sz="1100" b="1" spc="200" kern="0" dirty="0">
-                <a:solidFill>
-                  <a:schemeClr val="accent1"/>
-                </a:solidFill>
-              </a:rPr>
-              <a:t>SÅDAN</a:t>
-            </a:r>
-            <a:endParaRPr lang="en-US" sz="1100" dirty="0"/>
-          </a:p>
-        </p:txBody>
-      </p:sp>
-      <p:sp>
-        <p:nvSpPr>
-          <p:cNvPr id="15" name="Text 13"/>
-          <p:cNvSpPr txBox="1"/>
-          <p:nvPr/>
-        </p:nvSpPr>
-        <p:spPr>
-          <a:xfrm>
-            <a:off x="8503920" y="2926080"/>
-            <a:ext cx="2743200" cy="1463040"/>
-          </a:xfrm>
-          <a:prstGeom prst="rect">
-            <a:avLst/>
-          </a:prstGeom>
-          <a:noFill/>
-          <a:ln/>
-        </p:spPr>
-        <p:txBody>
-          <a:bodyPr wrap="square" lIns="0" tIns="0" rIns="0" bIns="0" rtlCol="0" anchor="t"/>
-          <a:lstStyle/>
-          <a:p>
-            <a:pPr indent="0" marL="0">
-              <a:buNone/>
-            </a:pPr>
-            <a:r>
-              <a:rPr lang="en-US" sz="1500" dirty="0">
-                <a:solidFill>
-                  <a:schemeClr val="bg1"/>
-                </a:solidFill>
-              </a:rPr>
-              <a:t>Åbn ChatGPT i Excel under Hjem og Tilføjelsesprogrammer. Bed om formlen til række 2, sæt den ind, og træk den ned.</a:t>
-            </a:r>
-            <a:endParaRPr lang="en-US" sz="1500" dirty="0"/>
-          </a:p>
-        </p:txBody>
-      </p:sp>
-      <p:sp>
-        <p:nvSpPr>
-          <p:cNvPr id="16" name="Text 14"/>
-          <p:cNvSpPr txBox="1"/>
-          <p:nvPr/>
-        </p:nvSpPr>
-        <p:spPr>
-          <a:xfrm>
-            <a:off x="8503920" y="4434840"/>
-            <a:ext cx="2743200" cy="640080"/>
-          </a:xfrm>
-          <a:prstGeom prst="rect">
-            <a:avLst/>
-          </a:prstGeom>
-          <a:noFill/>
-          <a:ln/>
-        </p:spPr>
-        <p:txBody>
-          <a:bodyPr wrap="square" lIns="0" tIns="0" rIns="0" bIns="0" rtlCol="0" anchor="t"/>
-          <a:lstStyle/>
-          <a:p>
-            <a:pPr indent="0" marL="0">
-              <a:buNone/>
-            </a:pPr>
-            <a:r>
-              <a:rPr lang="en-US" sz="1400" dirty="0">
-                <a:solidFill>
-                  <a:schemeClr val="accent3"/>
-                </a:solidFill>
-              </a:rPr>
-              <a:t>Tjek T-07 mod jeres egen udregning.</a:t>
-            </a:r>
-            <a:endParaRPr lang="en-US" sz="1400" dirty="0"/>
-          </a:p>
-        </p:txBody>
-      </p:sp>
-      <p:sp>
-        <p:nvSpPr>
-          <p:cNvPr id="17" name="Text 15"/>
+              <a:t>Sparringsprompten sætter ChatGPT til at spørge og forklare uden at give facit. Her gælder studiereglen.</a:t>
+            </a:r>
+            <a:endParaRPr lang="en-US" sz="1700" dirty="0"/>
+          </a:p>
+        </p:txBody>
+      </p:sp>
+      <p:sp>
+        <p:nvSpPr>
+          <p:cNvPr id="13" name="Text 11"/>
           <p:cNvSpPr txBox="1"/>
           <p:nvPr/>
         </p:nvSpPr>
@@ -19857,7 +19722,7 @@
                   <a:schemeClr val="accent3"/>
                 </a:solidFill>
               </a:rPr>
-              <a:t>De tre spørgsmål fra Opgave 13 i fanen Opgave. Prompterne står på opgavearket.</a:t>
+              <a:t>Arket med prompter og opgaver ligger under Materialer.</a:t>
             </a:r>
             <a:endParaRPr lang="en-US" sz="1200" dirty="0"/>
           </a:p>
@@ -20004,7 +19869,7 @@
                   <a:schemeClr val="bg1"/>
                 </a:solidFill>
               </a:rPr>
-              <a:t>Åbn fanen </a:t>
+              <a:t>Tilføj </a:t>
             </a:r>
             <a:pPr indent="0" marL="0">
               <a:buNone/>
@@ -20015,7 +19880,7 @@
                   <a:schemeClr val="accent1"/>
                 </a:solidFill>
               </a:rPr>
-              <a:t>Opgave</a:t>
+              <a:t>ChatGPT</a:t>
             </a:r>
             <a:pPr indent="0" marL="0">
               <a:buNone/>
@@ -20026,7 +19891,7 @@
                   <a:schemeClr val="bg1"/>
                 </a:solidFill>
               </a:rPr>
-              <a:t>, og lad ChatGPT i Excel skrive de tre formler. Tjek T-07 mod jeres udregning fra Opgave 13.</a:t>
+              <a:t> til Excel. Få overblik med tre prompts, og løs tre opgaver, hvor ChatGPT må spørge, men ikke give facit.</a:t>
             </a:r>
             <a:endParaRPr lang="en-US" sz="2600" dirty="0"/>
           </a:p>
@@ -20062,7 +19927,7 @@
                   <a:schemeClr val="accent3"/>
                 </a:solidFill>
               </a:rPr>
-              <a:t>Tjek tallet, før I tror på det.</a:t>
+              <a:t>Opgave 1 er Opgave 13. I kender facit.</a:t>
             </a:r>
             <a:endParaRPr lang="en-US" sz="2000" dirty="0"/>
           </a:p>
@@ -20157,12 +20022,13 @@
               <a:buNone/>
             </a:pPr>
             <a:r>
-              <a:rPr lang="en-US" sz="6600" b="1" dirty="0">
+              <a:rPr lang="en-US" sz="7200" b="1" dirty="0">
                 <a:solidFill>
                   <a:schemeClr val="bg1"/>
                 </a:solidFill>
               </a:rPr>
-              <a:t>Lad AI skrive formlen. </a:t>
+              <a:t>ChatGPT spørger.
+</a:t>
             </a:r>
             <a:pPr indent="0" marL="0">
               <a:lnSpc>
@@ -20171,14 +20037,14 @@
               <a:buNone/>
             </a:pPr>
             <a:r>
-              <a:rPr lang="en-US" sz="6600" b="1" dirty="0">
+              <a:rPr lang="en-US" sz="7200" b="1" dirty="0">
                 <a:solidFill>
                   <a:schemeClr val="accent1"/>
                 </a:solidFill>
               </a:rPr>
-              <a:t>Tjek tallet selv.</a:t>
-            </a:r>
-            <a:endParaRPr lang="en-US" sz="6600" dirty="0"/>
+              <a:t>I regner.</a:t>
+            </a:r>
+            <a:endParaRPr lang="en-US" sz="7200" dirty="0"/>
           </a:p>
         </p:txBody>
       </p:sp>

</xml_diff>

<commit_message>
QR-kode til Fugtloggen på live build-slidet
Co-Authored-By: Claude Fable 5.1 <noreply@anthropic.com>
Claude-Session: https://claude.ai/code/session_015YJpkwAMXruZRjbkCwcfYy
</commit_message>
<xml_diff>
--- a/private/proces/praesentation.pptx
+++ b/private/proces/praesentation.pptx
@@ -151,7 +151,7 @@
   <p:extLst>
     <p:ext uri="{521415D9-36F7-43E2-AB2F-B90AF26B5E84}">
       <p14:sectionLst xmlns:p14="http://schemas.microsoft.com/office/powerpoint/2010/main">
-        <p14:section name="Åbning" id="{3bc350fd-bd78-c2f9-7fb8-c9f1117497f6}">
+        <p14:section name="Åbning" id="{5b481082-e512-f844-94d2-9b55ddd54c51}">
           <p14:sldIdLst>
             <p14:sldId id="256"/>
             <p14:sldId id="257"/>
@@ -161,7 +161,7 @@
             <p14:sldId id="261"/>
           </p14:sldIdLst>
         </p14:section>
-        <p14:section name="Som studerende" id="{45d56ec3-1f0e-a7bb-2c03-523b0dd28407}">
+        <p14:section name="Som studerende" id="{668d0c4d-4743-9816-3cc8-a69bb4fa0237}">
           <p14:sldIdLst>
             <p14:sldId id="262"/>
             <p14:sldId id="263"/>
@@ -173,7 +173,7 @@
             <p14:sldId id="269"/>
           </p14:sldIdLst>
         </p14:section>
-        <p14:section name="Prompting" id="{1d490e1d-cef8-68c5-0d60-1963fe74c933}">
+        <p14:section name="Prompting" id="{e973c81d-46f2-be5e-2b7d-fb966c49dce7}">
           <p14:sldIdLst>
             <p14:sldId id="270"/>
             <p14:sldId id="271"/>
@@ -184,7 +184,7 @@
             <p14:sldId id="276"/>
           </p14:sldIdLst>
         </p14:section>
-        <p14:section name="Excel og data" id="{59cae7a7-b293-3cee-698c-3d2d4a53922c}">
+        <p14:section name="Excel og data" id="{d4e9e7c2-e0d7-0ec1-394c-1ef6d134ce94}">
           <p14:sldIdLst>
             <p14:sldId id="277"/>
             <p14:sldId id="278"/>
@@ -194,7 +194,7 @@
             <p14:sldId id="282"/>
           </p14:sldIdLst>
         </p14:section>
-        <p14:section name="AI i jobbet" id="{c01a538f-3a11-c805-7cca-5340bb06b563}">
+        <p14:section name="AI i jobbet" id="{f53b0457-c8bd-115f-a3e1-a0e8d3772a20}">
           <p14:sldIdLst>
             <p14:sldId id="283"/>
             <p14:sldId id="284"/>
@@ -207,7 +207,7 @@
             <p14:sldId id="291"/>
           </p14:sldIdLst>
         </p14:section>
-        <p14:section name="Vibecoding" id="{546da49e-10c5-8a4f-e1c8-f4836f298b9c}">
+        <p14:section name="Vibecoding" id="{8ef2c89d-b34e-5f79-73e5-98cae912c872}">
           <p14:sldIdLst>
             <p14:sldId id="292"/>
             <p14:sldId id="293"/>
@@ -217,7 +217,7 @@
             <p14:sldId id="297"/>
           </p14:sldIdLst>
         </p14:section>
-        <p14:section name="Afrunding" id="{cbdf887a-0669-825e-3a22-336280309eca}">
+        <p14:section name="Afrunding" id="{fa1e5ed4-7c95-71c4-d36c-d4f1ee72b667}">
           <p14:sldIdLst>
             <p14:sldId id="298"/>
             <p14:sldId id="299"/>
@@ -3796,7 +3796,7 @@
           <a:p>
             <a:r>
               <a:rPr lang="en-US" dirty="0"/>
-              <a:t>Erstat den stiplede firkant med en QR-kode til appens Vercel-adresse, før du underviser. Opret repo og Vercel-projekt på forhånd, så adressen er kendt. Tag ét forslag fra salen, og lav én runde mere.</a:t>
+              <a:t>QR-koden peger på proces-fugtlog.vercel.app. Opret repo og Vercel-projekt på forhånd, så adressen er kendt. Tag ét forslag fra salen, og lav én runde mere.</a:t>
             </a:r>
             <a:endParaRPr lang="en-US" dirty="0"/>
           </a:p>
@@ -18315,49 +18315,73 @@
             </a:avLst>
           </a:prstGeom>
           <a:solidFill>
-            <a:srgbClr val="1C1C1E"/>
+            <a:srgbClr val="FFFFFF"/>
           </a:solidFill>
-          <a:ln w="15875">
+          <a:ln w="12700">
             <a:solidFill>
-              <a:srgbClr val="A1A1A6"/>
+              <a:srgbClr val="FFFFFF"/>
             </a:solidFill>
-            <a:prstDash val="dash"/>
+            <a:prstDash val="solid"/>
           </a:ln>
         </p:spPr>
       </p:sp>
-      <p:sp>
-        <p:nvSpPr>
-          <p:cNvPr id="6" name="Text 4"/>
-          <p:cNvSpPr txBox="1"/>
-          <p:nvPr/>
-        </p:nvSpPr>
-        <p:spPr>
-          <a:xfrm>
-            <a:off x="8138160" y="3383280"/>
-            <a:ext cx="2743200" cy="914400"/>
-          </a:xfrm>
-          <a:prstGeom prst="rect">
-            <a:avLst/>
-          </a:prstGeom>
-          <a:noFill/>
-          <a:ln/>
-        </p:spPr>
-        <p:txBody>
-          <a:bodyPr wrap="square" lIns="0" tIns="0" rIns="0" bIns="0" rtlCol="0" anchor="ctr"/>
+      <p:pic>
+        <p:nvPicPr>
+          <p:cNvPr id="6" name="Image 0" descr="qr_proces_fugtlog.png">    </p:cNvPr>
+          <p:cNvPicPr>
+            <a:picLocks noChangeAspect="1"/>
+          </p:cNvPicPr>
+          <p:nvPr/>
+        </p:nvPicPr>
+        <p:blipFill>
+          <a:blip r:embed="rId1"/>
+          <a:stretch>
+            <a:fillRect/>
+          </a:stretch>
+        </p:blipFill>
+        <p:spPr>
+          <a:xfrm>
+            <a:off x="8001000" y="2377440"/>
+            <a:ext cx="3017520" cy="3017520"/>
+          </a:xfrm>
+          <a:prstGeom prst="rect">
+            <a:avLst/>
+          </a:prstGeom>
+        </p:spPr>
+      </p:pic>
+      <p:sp>
+        <p:nvSpPr>
+          <p:cNvPr id="7" name="Text 4"/>
+          <p:cNvSpPr txBox="1"/>
+          <p:nvPr/>
+        </p:nvSpPr>
+        <p:spPr>
+          <a:xfrm>
+            <a:off x="7863840" y="5623560"/>
+            <a:ext cx="3291840" cy="320040"/>
+          </a:xfrm>
+          <a:prstGeom prst="rect">
+            <a:avLst/>
+          </a:prstGeom>
+          <a:noFill/>
+          <a:ln/>
+        </p:spPr>
+        <p:txBody>
+          <a:bodyPr wrap="square" lIns="0" tIns="0" rIns="0" bIns="0" rtlCol="0" anchor="t"/>
           <a:lstStyle/>
           <a:p>
             <a:pPr algn="ctr" indent="0" marL="0">
               <a:buNone/>
             </a:pPr>
             <a:r>
-              <a:rPr lang="en-US" sz="1500" dirty="0">
+              <a:rPr lang="en-US" sz="1300" dirty="0">
                 <a:solidFill>
                   <a:schemeClr val="accent3"/>
                 </a:solidFill>
               </a:rPr>
-              <a:t>Indsæt QR-kode til Vercel-adressen</a:t>
-            </a:r>
-            <a:endParaRPr lang="en-US" sz="1500" dirty="0"/>
+              <a:t>proces-fugtlog.vercel.app</a:t>
+            </a:r>
+            <a:endParaRPr lang="en-US" sz="1300" dirty="0"/>
           </a:p>
         </p:txBody>
       </p:sp>

</xml_diff>

<commit_message>
Slide om Fugtloggen i hverdagen
Co-Authored-By: Claude Fable 5.1 <noreply@anthropic.com>
Claude-Session: https://claude.ai/code/session_015YJpkwAMXruZRjbkCwcfYy
</commit_message>
<xml_diff>
--- a/private/proces/praesentation.pptx
+++ b/private/proces/praesentation.pptx
@@ -50,9 +50,10 @@
     <p:sldId id="298" r:id="rId44"/>
     <p:sldId id="299" r:id="rId45"/>
     <p:sldId id="300" r:id="rId46"/>
+    <p:sldId id="301" r:id="rId47"/>
   </p:sldIdLst>
   <p:notesMasterIdLst>
-    <p:notesMasterId r:id="rId47"/>
+    <p:notesMasterId r:id="rId48"/>
   </p:notesMasterIdLst>
   <p:sldSz cx="12192000" cy="6858000"/>
   <p:notesSz cx="6858000" cy="12192000"/>
@@ -151,7 +152,7 @@
   <p:extLst>
     <p:ext uri="{521415D9-36F7-43E2-AB2F-B90AF26B5E84}">
       <p14:sectionLst xmlns:p14="http://schemas.microsoft.com/office/powerpoint/2010/main">
-        <p14:section name="Åbning" id="{5b481082-e512-f844-94d2-9b55ddd54c51}">
+        <p14:section name="Åbning" id="{b4229779-b561-27b2-4cbc-186b46434d52}">
           <p14:sldIdLst>
             <p14:sldId id="256"/>
             <p14:sldId id="257"/>
@@ -161,7 +162,7 @@
             <p14:sldId id="261"/>
           </p14:sldIdLst>
         </p14:section>
-        <p14:section name="Som studerende" id="{668d0c4d-4743-9816-3cc8-a69bb4fa0237}">
+        <p14:section name="Som studerende" id="{2a16b47a-f43e-585a-b61f-56f4bf3c4dc1}">
           <p14:sldIdLst>
             <p14:sldId id="262"/>
             <p14:sldId id="263"/>
@@ -173,7 +174,7 @@
             <p14:sldId id="269"/>
           </p14:sldIdLst>
         </p14:section>
-        <p14:section name="Prompting" id="{e973c81d-46f2-be5e-2b7d-fb966c49dce7}">
+        <p14:section name="Prompting" id="{1fccd9e6-1f83-f318-3dcc-5eb2f0ee3598}">
           <p14:sldIdLst>
             <p14:sldId id="270"/>
             <p14:sldId id="271"/>
@@ -184,7 +185,7 @@
             <p14:sldId id="276"/>
           </p14:sldIdLst>
         </p14:section>
-        <p14:section name="Excel og data" id="{d4e9e7c2-e0d7-0ec1-394c-1ef6d134ce94}">
+        <p14:section name="Excel og data" id="{fcd12f97-d186-22a7-83a4-f931f1063b98}">
           <p14:sldIdLst>
             <p14:sldId id="277"/>
             <p14:sldId id="278"/>
@@ -194,7 +195,7 @@
             <p14:sldId id="282"/>
           </p14:sldIdLst>
         </p14:section>
-        <p14:section name="AI i jobbet" id="{f53b0457-c8bd-115f-a3e1-a0e8d3772a20}">
+        <p14:section name="AI i jobbet" id="{421a7ca5-2471-ebd4-0a4b-1971af178080}">
           <p14:sldIdLst>
             <p14:sldId id="283"/>
             <p14:sldId id="284"/>
@@ -207,7 +208,7 @@
             <p14:sldId id="291"/>
           </p14:sldIdLst>
         </p14:section>
-        <p14:section name="Vibecoding" id="{8ef2c89d-b34e-5f79-73e5-98cae912c872}">
+        <p14:section name="Vibecoding" id="{09f69cb4-cac1-4b79-b1e8-9f4f2a2b7856}">
           <p14:sldIdLst>
             <p14:sldId id="292"/>
             <p14:sldId id="293"/>
@@ -215,13 +216,14 @@
             <p14:sldId id="295"/>
             <p14:sldId id="296"/>
             <p14:sldId id="297"/>
+            <p14:sldId id="298"/>
           </p14:sldIdLst>
         </p14:section>
-        <p14:section name="Afrunding" id="{fa1e5ed4-7c95-71c4-d36c-d4f1ee72b667}">
+        <p14:section name="Afrunding" id="{ee7edad7-f2c5-e4cf-d408-66ad24fda912}">
           <p14:sldIdLst>
-            <p14:sldId id="298"/>
             <p14:sldId id="299"/>
             <p14:sldId id="300"/>
+            <p14:sldId id="301"/>
           </p14:sldIdLst>
         </p14:section>
       </p14:sectionLst>
@@ -3796,7 +3798,7 @@
           <a:p>
             <a:r>
               <a:rPr lang="en-US" dirty="0"/>
-              <a:t>QR-koden peger på proces-fugtlog.vercel.app. Opret repo og Vercel-projekt på forhånd, så adressen er kendt. Tag ét forslag fra salen, og lav én runde mere.</a:t>
+              <a:t>På Fjordtørreriet i hverdagen. Operatøren går runden med telefonen i lommen. Ved hvert planlager trykker han lager og vare, taster vandindhold og lagtemperatur og gemmer. Det tager få sekunder, og dato, tid og initialer kommer automatisk med. Er en måling i orden, sker der ikke mere. Er den uden for grænsen, bliver skærmen rød, og appen nægter at gemme, før operatøren har skrevet, hvad han gør ved det. Det er hele pointen. Afvigelsen kan ikke bare noteres og glemmes, for den korrigerende handling bliver tvunget frem i samme øjeblik. Tælleren øverst giver formanden et hurtigt overblik. Står der 0, kører det. Står der 3 med rød baggrund, skal nogen kigge nærmere på det i dag.</a:t>
             </a:r>
             <a:endParaRPr lang="en-US" dirty="0"/>
           </a:p>
@@ -3884,7 +3886,7 @@
           <a:p>
             <a:r>
               <a:rPr lang="en-US" dirty="0"/>
-              <a:t>Afrunding. To regler, ét værktøj. Som studerende tænker I selv og bruger AI som sparringspartner. I jobbet bruger I AI fuldt ud, tager svarene, kører arbejdsgangene og bygger jeres egne værktøjer.</a:t>
+              <a:t>QR-koden peger på proces-fugtlog.vercel.app. Opret repo og Vercel-projekt på forhånd, så adressen er kendt. Tag ét forslag fra salen, og lav én runde mere.</a:t>
             </a:r>
             <a:endParaRPr lang="en-US" dirty="0"/>
           </a:p>
@@ -3972,7 +3974,7 @@
           <a:p>
             <a:r>
               <a:rPr lang="en-US" dirty="0"/>
-              <a:t>Exit ticket i Mentimeter eller på en seddel. Del datasæt, promptkort og promptbanken til studiet på læringsplatformen.</a:t>
+              <a:t>Afrunding. To regler, ét værktøj. Som studerende tænker I selv og bruger AI som sparringspartner. I jobbet bruger I AI fuldt ud, tager svarene, kører arbejdsgangene og bygger jeres egne værktøjer.</a:t>
             </a:r>
             <a:endParaRPr lang="en-US" dirty="0"/>
           </a:p>
@@ -4060,7 +4062,7 @@
           <a:p>
             <a:r>
               <a:rPr lang="en-US" dirty="0"/>
-              <a:t>Tak for i dag.</a:t>
+              <a:t>Exit ticket i Mentimeter eller på en seddel. Del datasæt, promptkort og promptbanken til studiet på læringsplatformen.</a:t>
             </a:r>
             <a:endParaRPr lang="en-US" dirty="0"/>
           </a:p>
@@ -4084,6 +4086,94 @@
             <a:fld id="{F7021451-1387-4CA6-816F-3879F97B5CBC}" type="slidenum">
               <a:rPr lang="en-US"/>
               <a:t>45</a:t>
+            </a:fld>
+            <a:endParaRPr lang="en-US"/>
+          </a:p>
+        </p:txBody>
+      </p:sp>
+    </p:spTree>
+    <p:extLst>
+      <p:ext uri="{BB962C8B-B14F-4D97-AF65-F5344CB8AC3E}">
+        <p14:creationId xmlns:p14="http://schemas.microsoft.com/office/powerpoint/2010/main" val="1024086991"/>
+      </p:ext>
+    </p:extLst>
+  </p:cSld>
+  <p:clrMapOvr>
+    <a:masterClrMapping/>
+  </p:clrMapOvr>
+</p:notes>
+</file>
+
+<file path=ppt/notesSlides/notesSlide46.xml><?xml version="1.0" encoding="utf-8"?>
+<p:notes xmlns:a="http://schemas.openxmlformats.org/drawingml/2006/main" xmlns:r="http://schemas.openxmlformats.org/officeDocument/2006/relationships" xmlns:p="http://schemas.openxmlformats.org/presentationml/2006/main">
+  <p:cSld>
+    <p:spTree>
+      <p:nvGrpSpPr>
+        <p:cNvPr id="1" name=""/>
+        <p:cNvGrpSpPr/>
+        <p:nvPr/>
+      </p:nvGrpSpPr>
+      <p:grpSpPr>
+        <a:xfrm>
+          <a:off x="0" y="0"/>
+          <a:ext cx="0" cy="0"/>
+          <a:chOff x="0" y="0"/>
+          <a:chExt cx="0" cy="0"/>
+        </a:xfrm>
+      </p:grpSpPr>
+      <p:sp>
+        <p:nvSpPr>
+          <p:cNvPr id="2" name="Slide Image Placeholder 1"/>
+          <p:cNvSpPr>
+            <a:spLocks noGrp="1" noRot="1" noChangeAspect="1"/>
+          </p:cNvSpPr>
+          <p:nvPr>
+            <p:ph type="sldImg"/>
+          </p:nvPr>
+        </p:nvSpPr>
+        <p:spPr/>
+      </p:sp>
+      <p:sp>
+        <p:nvSpPr>
+          <p:cNvPr id="3" name="Notes Placeholder 2"/>
+          <p:cNvSpPr>
+            <a:spLocks noGrp="1"/>
+          </p:cNvSpPr>
+          <p:nvPr>
+            <p:ph type="body" idx="1"/>
+          </p:nvPr>
+        </p:nvSpPr>
+        <p:spPr/>
+        <p:txBody>
+          <a:bodyPr/>
+          <a:lstStyle/>
+          <a:p>
+            <a:r>
+              <a:rPr lang="en-US" dirty="0"/>
+              <a:t>Tak for i dag.</a:t>
+            </a:r>
+            <a:endParaRPr lang="en-US" dirty="0"/>
+          </a:p>
+        </p:txBody>
+      </p:sp>
+      <p:sp>
+        <p:nvSpPr>
+          <p:cNvPr id="4" name="Slide Number Placeholder 3"/>
+          <p:cNvSpPr>
+            <a:spLocks noGrp="1"/>
+          </p:cNvSpPr>
+          <p:nvPr>
+            <p:ph type="sldNum" sz="quarter" idx="10"/>
+          </p:nvPr>
+        </p:nvSpPr>
+        <p:spPr/>
+        <p:txBody>
+          <a:bodyPr/>
+          <a:lstStyle/>
+          <a:p>
+            <a:fld id="{F7021451-1387-4CA6-816F-3879F97B5CBC}" type="slidenum">
+              <a:rPr lang="en-US"/>
+              <a:t>46</a:t>
             </a:fld>
             <a:endParaRPr lang="en-US"/>
           </a:p>
@@ -18201,7 +18291,7 @@
                   <a:schemeClr val="accent3"/>
                 </a:solidFill>
               </a:rPr>
-              <a:t>LIVE BUILD</a:t>
+              <a:t>FUGTLOGGEN  ·  PÅ FJORDTØRRERIET I HVERDAGEN</a:t>
             </a:r>
             <a:endParaRPr lang="en-US" sz="1200" dirty="0"/>
           </a:p>
@@ -18242,7 +18332,7 @@
                   <a:schemeClr val="bg1"/>
                 </a:solidFill>
               </a:rPr>
-              <a:t>Scan koden, og test appen, </a:t>
+              <a:t>Afvigelsen kan ikke </a:t>
             </a:r>
             <a:pPr algn="l" indent="0" marL="0">
               <a:lnSpc>
@@ -18256,7 +18346,7 @@
                   <a:schemeClr val="accent1"/>
                 </a:solidFill>
               </a:rPr>
-              <a:t>når den er online</a:t>
+              <a:t>noteres og glemmes</a:t>
             </a:r>
             <a:endParaRPr lang="en-US" sz="3400" dirty="0"/>
           </a:p>
@@ -18270,118 +18360,355 @@
         </p:nvSpPr>
         <p:spPr>
           <a:xfrm>
-            <a:off x="685800" y="2560320"/>
-            <a:ext cx="5669280" cy="1280160"/>
-          </a:xfrm>
-          <a:prstGeom prst="rect">
-            <a:avLst/>
-          </a:prstGeom>
-          <a:noFill/>
-          <a:ln/>
-        </p:spPr>
-        <p:txBody>
-          <a:bodyPr wrap="square" lIns="0" tIns="0" rIns="0" bIns="0" rtlCol="0" anchor="t"/>
-          <a:lstStyle/>
-          <a:p>
-            <a:pPr indent="0" marL="0">
-              <a:buNone/>
-            </a:pPr>
-            <a:r>
-              <a:rPr lang="en-US" sz="2400" dirty="0">
+            <a:off x="685800" y="2468880"/>
+            <a:ext cx="914400" cy="365760"/>
+          </a:xfrm>
+          <a:prstGeom prst="rect">
+            <a:avLst/>
+          </a:prstGeom>
+          <a:noFill/>
+          <a:ln/>
+        </p:spPr>
+        <p:txBody>
+          <a:bodyPr wrap="square" lIns="0" tIns="0" rIns="0" bIns="0" rtlCol="0" anchor="t"/>
+          <a:lstStyle/>
+          <a:p>
+            <a:pPr indent="0" marL="0">
+              <a:buNone/>
+            </a:pPr>
+            <a:r>
+              <a:rPr lang="en-US" sz="1600" b="1" dirty="0">
+                <a:solidFill>
+                  <a:schemeClr val="accent1"/>
+                </a:solidFill>
+              </a:rPr>
+              <a:t>01</a:t>
+            </a:r>
+            <a:endParaRPr lang="en-US" sz="1600" dirty="0"/>
+          </a:p>
+        </p:txBody>
+      </p:sp>
+      <p:sp>
+        <p:nvSpPr>
+          <p:cNvPr id="5" name="Text 3"/>
+          <p:cNvSpPr txBox="1"/>
+          <p:nvPr/>
+        </p:nvSpPr>
+        <p:spPr>
+          <a:xfrm>
+            <a:off x="685800" y="2880360"/>
+            <a:ext cx="3240938" cy="731520"/>
+          </a:xfrm>
+          <a:prstGeom prst="rect">
+            <a:avLst/>
+          </a:prstGeom>
+          <a:noFill/>
+          <a:ln/>
+        </p:spPr>
+        <p:txBody>
+          <a:bodyPr wrap="square" lIns="0" tIns="0" rIns="0" bIns="0" rtlCol="0" anchor="t"/>
+          <a:lstStyle/>
+          <a:p>
+            <a:pPr indent="0" marL="0">
+              <a:buNone/>
+            </a:pPr>
+            <a:r>
+              <a:rPr lang="en-US" sz="3400" b="1" dirty="0">
                 <a:solidFill>
                   <a:schemeClr val="bg1"/>
                 </a:solidFill>
               </a:rPr>
-              <a:t>Find en fejl, eller foreslå en forbedring. Så bygger vi én runde mere.</a:t>
-            </a:r>
-            <a:endParaRPr lang="en-US" sz="2400" dirty="0"/>
-          </a:p>
-        </p:txBody>
-      </p:sp>
-      <p:sp>
-        <p:nvSpPr>
-          <p:cNvPr id="5" name="Shape 3"/>
-          <p:cNvSpPr/>
-          <p:nvPr/>
-        </p:nvSpPr>
-        <p:spPr>
-          <a:xfrm>
-            <a:off x="7863840" y="2240280"/>
-            <a:ext cx="3291840" cy="3291840"/>
-          </a:xfrm>
-          <a:prstGeom prst="roundRect">
-            <a:avLst>
-              <a:gd name="adj" fmla="val 3333"/>
-            </a:avLst>
-          </a:prstGeom>
-          <a:solidFill>
-            <a:srgbClr val="FFFFFF"/>
-          </a:solidFill>
-          <a:ln w="12700">
-            <a:solidFill>
-              <a:srgbClr val="FFFFFF"/>
-            </a:solidFill>
-            <a:prstDash val="solid"/>
-          </a:ln>
-        </p:spPr>
-      </p:sp>
-      <p:pic>
-        <p:nvPicPr>
-          <p:cNvPr id="6" name="Image 0" descr="qr_proces_fugtlog.png">    </p:cNvPr>
-          <p:cNvPicPr>
-            <a:picLocks noChangeAspect="1"/>
-          </p:cNvPicPr>
-          <p:nvPr/>
-        </p:nvPicPr>
-        <p:blipFill>
-          <a:blip r:embed="rId1"/>
-          <a:stretch>
-            <a:fillRect/>
-          </a:stretch>
-        </p:blipFill>
-        <p:spPr>
-          <a:xfrm>
-            <a:off x="8001000" y="2377440"/>
-            <a:ext cx="3017520" cy="3017520"/>
-          </a:xfrm>
-          <a:prstGeom prst="rect">
-            <a:avLst/>
-          </a:prstGeom>
-        </p:spPr>
-      </p:pic>
-      <p:sp>
-        <p:nvSpPr>
-          <p:cNvPr id="7" name="Text 4"/>
-          <p:cNvSpPr txBox="1"/>
-          <p:nvPr/>
-        </p:nvSpPr>
-        <p:spPr>
-          <a:xfrm>
-            <a:off x="7863840" y="5623560"/>
-            <a:ext cx="3291840" cy="320040"/>
-          </a:xfrm>
-          <a:prstGeom prst="rect">
-            <a:avLst/>
-          </a:prstGeom>
-          <a:noFill/>
-          <a:ln/>
-        </p:spPr>
-        <p:txBody>
-          <a:bodyPr wrap="square" lIns="0" tIns="0" rIns="0" bIns="0" rtlCol="0" anchor="t"/>
-          <a:lstStyle/>
-          <a:p>
-            <a:pPr algn="ctr" indent="0" marL="0">
-              <a:buNone/>
-            </a:pPr>
-            <a:r>
-              <a:rPr lang="en-US" sz="1300" dirty="0">
+              <a:t>Runden</a:t>
+            </a:r>
+            <a:endParaRPr lang="en-US" sz="3400" dirty="0"/>
+          </a:p>
+        </p:txBody>
+      </p:sp>
+      <p:sp>
+        <p:nvSpPr>
+          <p:cNvPr id="6" name="Text 4"/>
+          <p:cNvSpPr txBox="1"/>
+          <p:nvPr/>
+        </p:nvSpPr>
+        <p:spPr>
+          <a:xfrm>
+            <a:off x="685800" y="3749040"/>
+            <a:ext cx="3149498" cy="1737360"/>
+          </a:xfrm>
+          <a:prstGeom prst="rect">
+            <a:avLst/>
+          </a:prstGeom>
+          <a:noFill/>
+          <a:ln/>
+        </p:spPr>
+        <p:txBody>
+          <a:bodyPr wrap="square" lIns="0" tIns="0" rIns="0" bIns="0" rtlCol="0" anchor="t"/>
+          <a:lstStyle/>
+          <a:p>
+            <a:pPr indent="0" marL="0">
+              <a:buNone/>
+            </a:pPr>
+            <a:r>
+              <a:rPr lang="en-US" sz="1700" dirty="0">
                 <a:solidFill>
                   <a:schemeClr val="accent3"/>
                 </a:solidFill>
               </a:rPr>
-              <a:t>proces-fugtlog.vercel.app</a:t>
-            </a:r>
-            <a:endParaRPr lang="en-US" sz="1300" dirty="0"/>
+              <a:t>Operatøren trykker lager og vare, taster vandindhold og lagtemperatur og gemmer. Få sekunder. Dato, tid og initialer kommer af sig selv.</a:t>
+            </a:r>
+            <a:endParaRPr lang="en-US" sz="1700" dirty="0"/>
+          </a:p>
+        </p:txBody>
+      </p:sp>
+      <p:sp>
+        <p:nvSpPr>
+          <p:cNvPr id="7" name="Text 5"/>
+          <p:cNvSpPr txBox="1"/>
+          <p:nvPr/>
+        </p:nvSpPr>
+        <p:spPr>
+          <a:xfrm>
+            <a:off x="4292498" y="2468880"/>
+            <a:ext cx="914400" cy="365760"/>
+          </a:xfrm>
+          <a:prstGeom prst="rect">
+            <a:avLst/>
+          </a:prstGeom>
+          <a:noFill/>
+          <a:ln/>
+        </p:spPr>
+        <p:txBody>
+          <a:bodyPr wrap="square" lIns="0" tIns="0" rIns="0" bIns="0" rtlCol="0" anchor="t"/>
+          <a:lstStyle/>
+          <a:p>
+            <a:pPr indent="0" marL="0">
+              <a:buNone/>
+            </a:pPr>
+            <a:r>
+              <a:rPr lang="en-US" sz="1600" b="1" dirty="0">
+                <a:solidFill>
+                  <a:schemeClr val="accent1"/>
+                </a:solidFill>
+              </a:rPr>
+              <a:t>02</a:t>
+            </a:r>
+            <a:endParaRPr lang="en-US" sz="1600" dirty="0"/>
+          </a:p>
+        </p:txBody>
+      </p:sp>
+      <p:sp>
+        <p:nvSpPr>
+          <p:cNvPr id="8" name="Text 6"/>
+          <p:cNvSpPr txBox="1"/>
+          <p:nvPr/>
+        </p:nvSpPr>
+        <p:spPr>
+          <a:xfrm>
+            <a:off x="4292498" y="2880360"/>
+            <a:ext cx="3240938" cy="731520"/>
+          </a:xfrm>
+          <a:prstGeom prst="rect">
+            <a:avLst/>
+          </a:prstGeom>
+          <a:noFill/>
+          <a:ln/>
+        </p:spPr>
+        <p:txBody>
+          <a:bodyPr wrap="square" lIns="0" tIns="0" rIns="0" bIns="0" rtlCol="0" anchor="t"/>
+          <a:lstStyle/>
+          <a:p>
+            <a:pPr indent="0" marL="0">
+              <a:buNone/>
+            </a:pPr>
+            <a:r>
+              <a:rPr lang="en-US" sz="3400" b="1" dirty="0">
+                <a:solidFill>
+                  <a:schemeClr val="bg1"/>
+                </a:solidFill>
+              </a:rPr>
+              <a:t>Afvigelsen</a:t>
+            </a:r>
+            <a:endParaRPr lang="en-US" sz="3400" dirty="0"/>
+          </a:p>
+        </p:txBody>
+      </p:sp>
+      <p:sp>
+        <p:nvSpPr>
+          <p:cNvPr id="9" name="Text 7"/>
+          <p:cNvSpPr txBox="1"/>
+          <p:nvPr/>
+        </p:nvSpPr>
+        <p:spPr>
+          <a:xfrm>
+            <a:off x="4292498" y="3749040"/>
+            <a:ext cx="3149498" cy="1737360"/>
+          </a:xfrm>
+          <a:prstGeom prst="rect">
+            <a:avLst/>
+          </a:prstGeom>
+          <a:noFill/>
+          <a:ln/>
+        </p:spPr>
+        <p:txBody>
+          <a:bodyPr wrap="square" lIns="0" tIns="0" rIns="0" bIns="0" rtlCol="0" anchor="t"/>
+          <a:lstStyle/>
+          <a:p>
+            <a:pPr indent="0" marL="0">
+              <a:buNone/>
+            </a:pPr>
+            <a:r>
+              <a:rPr lang="en-US" sz="1700" dirty="0">
+                <a:solidFill>
+                  <a:schemeClr val="accent3"/>
+                </a:solidFill>
+              </a:rPr>
+              <a:t>Er målingen uden for grænsen, bliver skærmen rød, og appen nægter at gemme, før operatøren har skrevet, hvad han gør ved det.</a:t>
+            </a:r>
+            <a:endParaRPr lang="en-US" sz="1700" dirty="0"/>
+          </a:p>
+        </p:txBody>
+      </p:sp>
+      <p:sp>
+        <p:nvSpPr>
+          <p:cNvPr id="10" name="Text 8"/>
+          <p:cNvSpPr txBox="1"/>
+          <p:nvPr/>
+        </p:nvSpPr>
+        <p:spPr>
+          <a:xfrm>
+            <a:off x="7899197" y="2468880"/>
+            <a:ext cx="914400" cy="365760"/>
+          </a:xfrm>
+          <a:prstGeom prst="rect">
+            <a:avLst/>
+          </a:prstGeom>
+          <a:noFill/>
+          <a:ln/>
+        </p:spPr>
+        <p:txBody>
+          <a:bodyPr wrap="square" lIns="0" tIns="0" rIns="0" bIns="0" rtlCol="0" anchor="t"/>
+          <a:lstStyle/>
+          <a:p>
+            <a:pPr indent="0" marL="0">
+              <a:buNone/>
+            </a:pPr>
+            <a:r>
+              <a:rPr lang="en-US" sz="1600" b="1" dirty="0">
+                <a:solidFill>
+                  <a:schemeClr val="accent1"/>
+                </a:solidFill>
+              </a:rPr>
+              <a:t>03</a:t>
+            </a:r>
+            <a:endParaRPr lang="en-US" sz="1600" dirty="0"/>
+          </a:p>
+        </p:txBody>
+      </p:sp>
+      <p:sp>
+        <p:nvSpPr>
+          <p:cNvPr id="11" name="Text 9"/>
+          <p:cNvSpPr txBox="1"/>
+          <p:nvPr/>
+        </p:nvSpPr>
+        <p:spPr>
+          <a:xfrm>
+            <a:off x="7899197" y="2880360"/>
+            <a:ext cx="3240938" cy="731520"/>
+          </a:xfrm>
+          <a:prstGeom prst="rect">
+            <a:avLst/>
+          </a:prstGeom>
+          <a:noFill/>
+          <a:ln/>
+        </p:spPr>
+        <p:txBody>
+          <a:bodyPr wrap="square" lIns="0" tIns="0" rIns="0" bIns="0" rtlCol="0" anchor="t"/>
+          <a:lstStyle/>
+          <a:p>
+            <a:pPr indent="0" marL="0">
+              <a:buNone/>
+            </a:pPr>
+            <a:r>
+              <a:rPr lang="en-US" sz="3400" b="1" dirty="0">
+                <a:solidFill>
+                  <a:schemeClr val="bg1"/>
+                </a:solidFill>
+              </a:rPr>
+              <a:t>Tælleren</a:t>
+            </a:r>
+            <a:endParaRPr lang="en-US" sz="3400" dirty="0"/>
+          </a:p>
+        </p:txBody>
+      </p:sp>
+      <p:sp>
+        <p:nvSpPr>
+          <p:cNvPr id="12" name="Text 10"/>
+          <p:cNvSpPr txBox="1"/>
+          <p:nvPr/>
+        </p:nvSpPr>
+        <p:spPr>
+          <a:xfrm>
+            <a:off x="7899197" y="3749040"/>
+            <a:ext cx="3149498" cy="1737360"/>
+          </a:xfrm>
+          <a:prstGeom prst="rect">
+            <a:avLst/>
+          </a:prstGeom>
+          <a:noFill/>
+          <a:ln/>
+        </p:spPr>
+        <p:txBody>
+          <a:bodyPr wrap="square" lIns="0" tIns="0" rIns="0" bIns="0" rtlCol="0" anchor="t"/>
+          <a:lstStyle/>
+          <a:p>
+            <a:pPr indent="0" marL="0">
+              <a:buNone/>
+            </a:pPr>
+            <a:r>
+              <a:rPr lang="en-US" sz="1700" dirty="0">
+                <a:solidFill>
+                  <a:schemeClr val="accent3"/>
+                </a:solidFill>
+              </a:rPr>
+              <a:t>0 betyder, at det kører. 3 med rød baggrund betyder, at nogen skal kigge nærmere på det i dag.</a:t>
+            </a:r>
+            <a:endParaRPr lang="en-US" sz="1700" dirty="0"/>
+          </a:p>
+        </p:txBody>
+      </p:sp>
+      <p:sp>
+        <p:nvSpPr>
+          <p:cNvPr id="13" name="Text 11"/>
+          <p:cNvSpPr txBox="1"/>
+          <p:nvPr/>
+        </p:nvSpPr>
+        <p:spPr>
+          <a:xfrm>
+            <a:off x="685800" y="6144768"/>
+            <a:ext cx="10820095" cy="320040"/>
+          </a:xfrm>
+          <a:prstGeom prst="rect">
+            <a:avLst/>
+          </a:prstGeom>
+          <a:noFill/>
+          <a:ln/>
+        </p:spPr>
+        <p:txBody>
+          <a:bodyPr wrap="square" lIns="0" tIns="0" rIns="0" bIns="0" rtlCol="0" anchor="t"/>
+          <a:lstStyle/>
+          <a:p>
+            <a:pPr indent="0" marL="0">
+              <a:buNone/>
+            </a:pPr>
+            <a:r>
+              <a:rPr lang="en-US" sz="1200" dirty="0">
+                <a:solidFill>
+                  <a:schemeClr val="accent3"/>
+                </a:solidFill>
+              </a:rPr>
+              <a:t>Den korrigerende handling bliver tvunget frem i samme øjeblik. Det er hele pointen.</a:t>
+            </a:r>
+            <a:endParaRPr lang="en-US" sz="1200" dirty="0"/>
           </a:p>
         </p:txBody>
       </p:sp>
@@ -18412,282 +18739,215 @@
       </p:grpSpPr>
       <p:sp>
         <p:nvSpPr>
-          <p:cNvPr id="2" name="Shape 0"/>
+          <p:cNvPr id="2" name="Text 0"/>
+          <p:cNvSpPr txBox="1"/>
+          <p:nvPr/>
+        </p:nvSpPr>
+        <p:spPr>
+          <a:xfrm>
+            <a:off x="685800" y="411480"/>
+            <a:ext cx="8229600" cy="274320"/>
+          </a:xfrm>
+          <a:prstGeom prst="rect">
+            <a:avLst/>
+          </a:prstGeom>
+          <a:noFill/>
+          <a:ln/>
+        </p:spPr>
+        <p:txBody>
+          <a:bodyPr wrap="square" lIns="0" tIns="0" rIns="0" bIns="0" rtlCol="0" anchor="t"/>
+          <a:lstStyle/>
+          <a:p>
+            <a:pPr indent="0" marL="0">
+              <a:buNone/>
+            </a:pPr>
+            <a:r>
+              <a:rPr lang="en-US" sz="1200" b="1" spc="200" kern="0" dirty="0">
+                <a:solidFill>
+                  <a:schemeClr val="accent3"/>
+                </a:solidFill>
+              </a:rPr>
+              <a:t>LIVE BUILD</a:t>
+            </a:r>
+            <a:endParaRPr lang="en-US" sz="1200" dirty="0"/>
+          </a:p>
+        </p:txBody>
+      </p:sp>
+      <p:sp>
+        <p:nvSpPr>
+          <p:cNvPr id="3" name="Text 0"/>
           <p:cNvSpPr/>
-          <p:nvPr/>
-        </p:nvSpPr>
-        <p:spPr>
-          <a:xfrm>
-            <a:off x="6095848" y="0"/>
-            <a:ext cx="6095848" cy="6858000"/>
-          </a:xfrm>
-          <a:prstGeom prst="rect">
-            <a:avLst/>
+          <p:nvPr>
+            <p:ph idx="100" type="title" hasCustomPrompt="1"/>
+          </p:nvPr>
+        </p:nvSpPr>
+        <p:spPr>
+          <a:xfrm>
+            <a:off x="685800" y="804672"/>
+            <a:ext cx="10820095" cy="1280160"/>
+          </a:xfrm>
+          <a:prstGeom prst="rect">
+            <a:avLst/>
+          </a:prstGeom>
+          <a:noFill/>
+          <a:ln/>
+        </p:spPr>
+        <p:txBody>
+          <a:bodyPr wrap="square" lIns="0" tIns="0" rIns="0" bIns="0" rtlCol="0" anchor="t"/>
+          <a:lstStyle/>
+          <a:p>
+            <a:pPr algn="l" indent="0" marL="0">
+              <a:lnSpc>
+                <a:spcPct val="93000"/>
+              </a:lnSpc>
+              <a:buNone/>
+            </a:pPr>
+            <a:r>
+              <a:rPr lang="en-US" sz="3400" b="1" dirty="0">
+                <a:solidFill>
+                  <a:schemeClr val="bg1"/>
+                </a:solidFill>
+              </a:rPr>
+              <a:t>Scan koden, og test appen, </a:t>
+            </a:r>
+            <a:pPr algn="l" indent="0" marL="0">
+              <a:lnSpc>
+                <a:spcPct val="93000"/>
+              </a:lnSpc>
+              <a:buNone/>
+            </a:pPr>
+            <a:r>
+              <a:rPr lang="en-US" sz="3400" b="1" dirty="0">
+                <a:solidFill>
+                  <a:schemeClr val="accent1"/>
+                </a:solidFill>
+              </a:rPr>
+              <a:t>når den er online</a:t>
+            </a:r>
+            <a:endParaRPr lang="en-US" sz="3400" dirty="0"/>
+          </a:p>
+        </p:txBody>
+      </p:sp>
+      <p:sp>
+        <p:nvSpPr>
+          <p:cNvPr id="4" name="Text 2"/>
+          <p:cNvSpPr txBox="1"/>
+          <p:nvPr/>
+        </p:nvSpPr>
+        <p:spPr>
+          <a:xfrm>
+            <a:off x="685800" y="2560320"/>
+            <a:ext cx="5669280" cy="1280160"/>
+          </a:xfrm>
+          <a:prstGeom prst="rect">
+            <a:avLst/>
+          </a:prstGeom>
+          <a:noFill/>
+          <a:ln/>
+        </p:spPr>
+        <p:txBody>
+          <a:bodyPr wrap="square" lIns="0" tIns="0" rIns="0" bIns="0" rtlCol="0" anchor="t"/>
+          <a:lstStyle/>
+          <a:p>
+            <a:pPr indent="0" marL="0">
+              <a:buNone/>
+            </a:pPr>
+            <a:r>
+              <a:rPr lang="en-US" sz="2400" dirty="0">
+                <a:solidFill>
+                  <a:schemeClr val="bg1"/>
+                </a:solidFill>
+              </a:rPr>
+              <a:t>Find en fejl, eller foreslå en forbedring. Så bygger vi én runde mere.</a:t>
+            </a:r>
+            <a:endParaRPr lang="en-US" sz="2400" dirty="0"/>
+          </a:p>
+        </p:txBody>
+      </p:sp>
+      <p:sp>
+        <p:nvSpPr>
+          <p:cNvPr id="5" name="Shape 3"/>
+          <p:cNvSpPr/>
+          <p:nvPr/>
+        </p:nvSpPr>
+        <p:spPr>
+          <a:xfrm>
+            <a:off x="7863840" y="2240280"/>
+            <a:ext cx="3291840" cy="3291840"/>
+          </a:xfrm>
+          <a:prstGeom prst="roundRect">
+            <a:avLst>
+              <a:gd name="adj" fmla="val 3333"/>
+            </a:avLst>
           </a:prstGeom>
           <a:solidFill>
-            <a:srgbClr val="0B0B0C"/>
+            <a:srgbClr val="FFFFFF"/>
           </a:solidFill>
           <a:ln w="12700">
             <a:solidFill>
-              <a:srgbClr val="0B0B0C"/>
+              <a:srgbClr val="FFFFFF"/>
             </a:solidFill>
             <a:prstDash val="solid"/>
           </a:ln>
         </p:spPr>
       </p:sp>
-      <p:sp>
-        <p:nvSpPr>
-          <p:cNvPr id="3" name="Text 1"/>
-          <p:cNvSpPr txBox="1"/>
-          <p:nvPr/>
-        </p:nvSpPr>
-        <p:spPr>
-          <a:xfrm>
-            <a:off x="685800" y="1737360"/>
-            <a:ext cx="4572000" cy="274320"/>
-          </a:xfrm>
-          <a:prstGeom prst="rect">
-            <a:avLst/>
-          </a:prstGeom>
-          <a:noFill/>
-          <a:ln/>
-        </p:spPr>
-        <p:txBody>
-          <a:bodyPr wrap="square" lIns="0" tIns="0" rIns="0" bIns="0" rtlCol="0" anchor="t"/>
-          <a:lstStyle/>
-          <a:p>
-            <a:pPr indent="0" marL="0">
-              <a:buNone/>
-            </a:pPr>
-            <a:r>
-              <a:rPr lang="en-US" sz="1200" b="1" spc="200" kern="0" dirty="0">
-                <a:solidFill>
-                  <a:schemeClr val="accent2"/>
-                </a:solidFill>
-              </a:rPr>
-              <a:t>SOM STUDERENDE</a:t>
-            </a:r>
-            <a:endParaRPr lang="en-US" sz="1200" dirty="0"/>
-          </a:p>
-        </p:txBody>
-      </p:sp>
-      <p:sp>
-        <p:nvSpPr>
-          <p:cNvPr id="4" name="Text 2"/>
-          <p:cNvSpPr txBox="1"/>
-          <p:nvPr/>
-        </p:nvSpPr>
-        <p:spPr>
-          <a:xfrm>
-            <a:off x="685800" y="2103120"/>
-            <a:ext cx="5044288" cy="2194560"/>
-          </a:xfrm>
-          <a:prstGeom prst="rect">
-            <a:avLst/>
-          </a:prstGeom>
-          <a:noFill/>
-          <a:ln/>
-        </p:spPr>
-        <p:txBody>
-          <a:bodyPr wrap="square" lIns="0" tIns="0" rIns="0" bIns="0" rtlCol="0" anchor="t"/>
-          <a:lstStyle/>
-          <a:p>
-            <a:pPr indent="0" marL="0">
-              <a:lnSpc>
-                <a:spcPct val="90000"/>
-              </a:lnSpc>
-              <a:buNone/>
-            </a:pPr>
-            <a:r>
-              <a:rPr lang="en-US" sz="6400" b="1" dirty="0">
-                <a:solidFill>
-                  <a:schemeClr val="tx1"/>
-                </a:solidFill>
-              </a:rPr>
-              <a:t>Tænk</a:t>
-            </a:r>
-            <a:endParaRPr lang="en-US" sz="6400" dirty="0"/>
-          </a:p>
-          <a:p>
-            <a:pPr indent="0" marL="0">
-              <a:lnSpc>
-                <a:spcPct val="90000"/>
-              </a:lnSpc>
-              <a:buNone/>
-            </a:pPr>
-            <a:r>
-              <a:rPr lang="en-US" sz="6400" b="1" dirty="0">
-                <a:solidFill>
-                  <a:schemeClr val="tx1"/>
-                </a:solidFill>
-              </a:rPr>
-              <a:t>selv.</a:t>
-            </a:r>
-            <a:endParaRPr lang="en-US" sz="6400" dirty="0"/>
-          </a:p>
-        </p:txBody>
-      </p:sp>
-      <p:sp>
-        <p:nvSpPr>
-          <p:cNvPr id="5" name="Text 3"/>
-          <p:cNvSpPr txBox="1"/>
-          <p:nvPr/>
-        </p:nvSpPr>
-        <p:spPr>
-          <a:xfrm>
-            <a:off x="685800" y="4526280"/>
-            <a:ext cx="4678528" cy="914400"/>
-          </a:xfrm>
-          <a:prstGeom prst="rect">
-            <a:avLst/>
-          </a:prstGeom>
-          <a:noFill/>
-          <a:ln/>
-        </p:spPr>
-        <p:txBody>
-          <a:bodyPr wrap="square" lIns="0" tIns="0" rIns="0" bIns="0" rtlCol="0" anchor="t"/>
-          <a:lstStyle/>
-          <a:p>
-            <a:pPr indent="0" marL="0">
-              <a:buNone/>
-            </a:pPr>
-            <a:r>
-              <a:rPr lang="en-US" sz="1900" dirty="0">
-                <a:solidFill>
-                  <a:schemeClr val="accent2"/>
-                </a:solidFill>
-              </a:rPr>
-              <a:t>Lær det først. Brug AI som sparringspartner.</a:t>
-            </a:r>
-            <a:endParaRPr lang="en-US" sz="1900" dirty="0"/>
-          </a:p>
-        </p:txBody>
-      </p:sp>
-      <p:sp>
-        <p:nvSpPr>
-          <p:cNvPr id="6" name="Text 4"/>
-          <p:cNvSpPr txBox="1"/>
-          <p:nvPr/>
-        </p:nvSpPr>
-        <p:spPr>
-          <a:xfrm>
-            <a:off x="6644488" y="1737360"/>
-            <a:ext cx="4572000" cy="274320"/>
-          </a:xfrm>
-          <a:prstGeom prst="rect">
-            <a:avLst/>
-          </a:prstGeom>
-          <a:noFill/>
-          <a:ln/>
-        </p:spPr>
-        <p:txBody>
-          <a:bodyPr wrap="square" lIns="0" tIns="0" rIns="0" bIns="0" rtlCol="0" anchor="t"/>
-          <a:lstStyle/>
-          <a:p>
-            <a:pPr indent="0" marL="0">
-              <a:buNone/>
-            </a:pPr>
-            <a:r>
-              <a:rPr lang="en-US" sz="1200" b="1" spc="200" kern="0" dirty="0">
-                <a:solidFill>
-                  <a:schemeClr val="accent1"/>
-                </a:solidFill>
-              </a:rPr>
-              <a:t>I JOBBET</a:t>
-            </a:r>
-            <a:endParaRPr lang="en-US" sz="1200" dirty="0"/>
-          </a:p>
-        </p:txBody>
-      </p:sp>
-      <p:sp>
-        <p:nvSpPr>
-          <p:cNvPr id="7" name="Text 5"/>
-          <p:cNvSpPr txBox="1"/>
-          <p:nvPr/>
-        </p:nvSpPr>
-        <p:spPr>
-          <a:xfrm>
-            <a:off x="6644488" y="2103120"/>
-            <a:ext cx="4998568" cy="2194560"/>
-          </a:xfrm>
-          <a:prstGeom prst="rect">
-            <a:avLst/>
-          </a:prstGeom>
-          <a:noFill/>
-          <a:ln/>
-        </p:spPr>
-        <p:txBody>
-          <a:bodyPr wrap="square" lIns="0" tIns="0" rIns="0" bIns="0" rtlCol="0" anchor="t"/>
-          <a:lstStyle/>
-          <a:p>
-            <a:pPr indent="0" marL="0">
-              <a:lnSpc>
-                <a:spcPct val="90000"/>
-              </a:lnSpc>
-              <a:buNone/>
-            </a:pPr>
-            <a:r>
-              <a:rPr lang="en-US" sz="6400" b="1" dirty="0">
-                <a:solidFill>
-                  <a:schemeClr val="bg1"/>
-                </a:solidFill>
-              </a:rPr>
-              <a:t>Brug AI</a:t>
-            </a:r>
-            <a:endParaRPr lang="en-US" sz="6400" dirty="0"/>
-          </a:p>
-          <a:p>
-            <a:pPr indent="0" marL="0">
-              <a:lnSpc>
-                <a:spcPct val="90000"/>
-              </a:lnSpc>
-              <a:buNone/>
-            </a:pPr>
-            <a:r>
-              <a:rPr lang="en-US" sz="6400" b="1" dirty="0">
-                <a:solidFill>
-                  <a:schemeClr val="accent1"/>
-                </a:solidFill>
-              </a:rPr>
-              <a:t>fuldt ud.</a:t>
-            </a:r>
-            <a:endParaRPr lang="en-US" sz="6400" dirty="0"/>
-          </a:p>
-        </p:txBody>
-      </p:sp>
-      <p:sp>
-        <p:nvSpPr>
-          <p:cNvPr id="8" name="Text 6"/>
-          <p:cNvSpPr txBox="1"/>
-          <p:nvPr/>
-        </p:nvSpPr>
-        <p:spPr>
-          <a:xfrm>
-            <a:off x="6644488" y="4526280"/>
-            <a:ext cx="4815688" cy="914400"/>
-          </a:xfrm>
-          <a:prstGeom prst="rect">
-            <a:avLst/>
-          </a:prstGeom>
-          <a:noFill/>
-          <a:ln/>
-        </p:spPr>
-        <p:txBody>
-          <a:bodyPr wrap="square" lIns="0" tIns="0" rIns="0" bIns="0" rtlCol="0" anchor="t"/>
-          <a:lstStyle/>
-          <a:p>
-            <a:pPr indent="0" marL="0">
-              <a:buNone/>
-            </a:pPr>
-            <a:r>
-              <a:rPr lang="en-US" sz="1900" dirty="0">
+      <p:pic>
+        <p:nvPicPr>
+          <p:cNvPr id="6" name="Image 0" descr="qr_proces_fugtlog.png">    </p:cNvPr>
+          <p:cNvPicPr>
+            <a:picLocks noChangeAspect="1"/>
+          </p:cNvPicPr>
+          <p:nvPr/>
+        </p:nvPicPr>
+        <p:blipFill>
+          <a:blip r:embed="rId1"/>
+          <a:stretch>
+            <a:fillRect/>
+          </a:stretch>
+        </p:blipFill>
+        <p:spPr>
+          <a:xfrm>
+            <a:off x="8001000" y="2377440"/>
+            <a:ext cx="3017520" cy="3017520"/>
+          </a:xfrm>
+          <a:prstGeom prst="rect">
+            <a:avLst/>
+          </a:prstGeom>
+        </p:spPr>
+      </p:pic>
+      <p:sp>
+        <p:nvSpPr>
+          <p:cNvPr id="7" name="Text 4"/>
+          <p:cNvSpPr txBox="1"/>
+          <p:nvPr/>
+        </p:nvSpPr>
+        <p:spPr>
+          <a:xfrm>
+            <a:off x="7863840" y="5623560"/>
+            <a:ext cx="3291840" cy="320040"/>
+          </a:xfrm>
+          <a:prstGeom prst="rect">
+            <a:avLst/>
+          </a:prstGeom>
+          <a:noFill/>
+          <a:ln/>
+        </p:spPr>
+        <p:txBody>
+          <a:bodyPr wrap="square" lIns="0" tIns="0" rIns="0" bIns="0" rtlCol="0" anchor="t"/>
+          <a:lstStyle/>
+          <a:p>
+            <a:pPr algn="ctr" indent="0" marL="0">
+              <a:buNone/>
+            </a:pPr>
+            <a:r>
+              <a:rPr lang="en-US" sz="1300" dirty="0">
                 <a:solidFill>
                   <a:schemeClr val="accent3"/>
                 </a:solidFill>
               </a:rPr>
-              <a:t>Tag svarene. Kør arbejdsgangene. Byg dine egne værktøjer.</a:t>
-            </a:r>
-            <a:endParaRPr lang="en-US" sz="1900" dirty="0"/>
+              <a:t>proces-fugtlog.vercel.app</a:t>
+            </a:r>
+            <a:endParaRPr lang="en-US" sz="1300" dirty="0"/>
           </a:p>
         </p:txBody>
       </p:sp>
@@ -18718,14 +18978,39 @@
       </p:grpSpPr>
       <p:sp>
         <p:nvSpPr>
-          <p:cNvPr id="2" name="Text 0"/>
-          <p:cNvSpPr txBox="1"/>
-          <p:nvPr/>
-        </p:nvSpPr>
-        <p:spPr>
-          <a:xfrm>
-            <a:off x="685800" y="411480"/>
-            <a:ext cx="8229600" cy="274320"/>
+          <p:cNvPr id="2" name="Shape 0"/>
+          <p:cNvSpPr/>
+          <p:nvPr/>
+        </p:nvSpPr>
+        <p:spPr>
+          <a:xfrm>
+            <a:off x="6095848" y="0"/>
+            <a:ext cx="6095848" cy="6858000"/>
+          </a:xfrm>
+          <a:prstGeom prst="rect">
+            <a:avLst/>
+          </a:prstGeom>
+          <a:solidFill>
+            <a:srgbClr val="0B0B0C"/>
+          </a:solidFill>
+          <a:ln w="12700">
+            <a:solidFill>
+              <a:srgbClr val="0B0B0C"/>
+            </a:solidFill>
+            <a:prstDash val="solid"/>
+          </a:ln>
+        </p:spPr>
+      </p:sp>
+      <p:sp>
+        <p:nvSpPr>
+          <p:cNvPr id="3" name="Text 1"/>
+          <p:cNvSpPr txBox="1"/>
+          <p:nvPr/>
+        </p:nvSpPr>
+        <p:spPr>
+          <a:xfrm>
+            <a:off x="685800" y="1737360"/>
+            <a:ext cx="4572000" cy="274320"/>
           </a:xfrm>
           <a:prstGeom prst="rect">
             <a:avLst/>
@@ -18746,7 +19031,7 @@
                   <a:schemeClr val="accent2"/>
                 </a:solidFill>
               </a:rPr>
-              <a:t>EXIT TICKET</a:t>
+              <a:t>SOM STUDERENDE</a:t>
             </a:r>
             <a:endParaRPr lang="en-US" sz="1200" dirty="0"/>
           </a:p>
@@ -18754,214 +19039,221 @@
       </p:sp>
       <p:sp>
         <p:nvSpPr>
-          <p:cNvPr id="3" name="Text 0"/>
-          <p:cNvSpPr/>
-          <p:nvPr>
-            <p:ph idx="100" type="title" hasCustomPrompt="1"/>
-          </p:nvPr>
-        </p:nvSpPr>
-        <p:spPr>
-          <a:xfrm>
-            <a:off x="685800" y="804672"/>
-            <a:ext cx="10820095" cy="1280160"/>
-          </a:xfrm>
-          <a:prstGeom prst="rect">
-            <a:avLst/>
-          </a:prstGeom>
-          <a:noFill/>
-          <a:ln/>
-        </p:spPr>
-        <p:txBody>
-          <a:bodyPr wrap="square" lIns="0" tIns="0" rIns="0" bIns="0" rtlCol="0" anchor="t"/>
-          <a:lstStyle/>
-          <a:p>
-            <a:pPr algn="l" indent="0" marL="0">
+          <p:cNvPr id="4" name="Text 2"/>
+          <p:cNvSpPr txBox="1"/>
+          <p:nvPr/>
+        </p:nvSpPr>
+        <p:spPr>
+          <a:xfrm>
+            <a:off x="685800" y="2103120"/>
+            <a:ext cx="5044288" cy="2194560"/>
+          </a:xfrm>
+          <a:prstGeom prst="rect">
+            <a:avLst/>
+          </a:prstGeom>
+          <a:noFill/>
+          <a:ln/>
+        </p:spPr>
+        <p:txBody>
+          <a:bodyPr wrap="square" lIns="0" tIns="0" rIns="0" bIns="0" rtlCol="0" anchor="t"/>
+          <a:lstStyle/>
+          <a:p>
+            <a:pPr indent="0" marL="0">
               <a:lnSpc>
-                <a:spcPct val="93000"/>
+                <a:spcPct val="90000"/>
               </a:lnSpc>
               <a:buNone/>
             </a:pPr>
             <a:r>
-              <a:rPr lang="en-US" sz="3400" b="1" dirty="0">
+              <a:rPr lang="en-US" sz="6400" b="1" dirty="0">
                 <a:solidFill>
                   <a:schemeClr val="tx1"/>
                 </a:solidFill>
               </a:rPr>
-              <a:t>Skriv </a:t>
-            </a:r>
-            <a:pPr algn="l" indent="0" marL="0">
+              <a:t>Tænk</a:t>
+            </a:r>
+            <a:endParaRPr lang="en-US" sz="6400" dirty="0"/>
+          </a:p>
+          <a:p>
+            <a:pPr indent="0" marL="0">
               <a:lnSpc>
-                <a:spcPct val="93000"/>
+                <a:spcPct val="90000"/>
               </a:lnSpc>
               <a:buNone/>
             </a:pPr>
             <a:r>
-              <a:rPr lang="en-US" sz="3400" b="1" dirty="0">
+              <a:rPr lang="en-US" sz="6400" b="1" dirty="0">
+                <a:solidFill>
+                  <a:schemeClr val="tx1"/>
+                </a:solidFill>
+              </a:rPr>
+              <a:t>selv.</a:t>
+            </a:r>
+            <a:endParaRPr lang="en-US" sz="6400" dirty="0"/>
+          </a:p>
+        </p:txBody>
+      </p:sp>
+      <p:sp>
+        <p:nvSpPr>
+          <p:cNvPr id="5" name="Text 3"/>
+          <p:cNvSpPr txBox="1"/>
+          <p:nvPr/>
+        </p:nvSpPr>
+        <p:spPr>
+          <a:xfrm>
+            <a:off x="685800" y="4526280"/>
+            <a:ext cx="4678528" cy="914400"/>
+          </a:xfrm>
+          <a:prstGeom prst="rect">
+            <a:avLst/>
+          </a:prstGeom>
+          <a:noFill/>
+          <a:ln/>
+        </p:spPr>
+        <p:txBody>
+          <a:bodyPr wrap="square" lIns="0" tIns="0" rIns="0" bIns="0" rtlCol="0" anchor="t"/>
+          <a:lstStyle/>
+          <a:p>
+            <a:pPr indent="0" marL="0">
+              <a:buNone/>
+            </a:pPr>
+            <a:r>
+              <a:rPr lang="en-US" sz="1900" dirty="0">
+                <a:solidFill>
+                  <a:schemeClr val="accent2"/>
+                </a:solidFill>
+              </a:rPr>
+              <a:t>Lær det først. Brug AI som sparringspartner.</a:t>
+            </a:r>
+            <a:endParaRPr lang="en-US" sz="1900" dirty="0"/>
+          </a:p>
+        </p:txBody>
+      </p:sp>
+      <p:sp>
+        <p:nvSpPr>
+          <p:cNvPr id="6" name="Text 4"/>
+          <p:cNvSpPr txBox="1"/>
+          <p:nvPr/>
+        </p:nvSpPr>
+        <p:spPr>
+          <a:xfrm>
+            <a:off x="6644488" y="1737360"/>
+            <a:ext cx="4572000" cy="274320"/>
+          </a:xfrm>
+          <a:prstGeom prst="rect">
+            <a:avLst/>
+          </a:prstGeom>
+          <a:noFill/>
+          <a:ln/>
+        </p:spPr>
+        <p:txBody>
+          <a:bodyPr wrap="square" lIns="0" tIns="0" rIns="0" bIns="0" rtlCol="0" anchor="t"/>
+          <a:lstStyle/>
+          <a:p>
+            <a:pPr indent="0" marL="0">
+              <a:buNone/>
+            </a:pPr>
+            <a:r>
+              <a:rPr lang="en-US" sz="1200" b="1" spc="200" kern="0" dirty="0">
                 <a:solidFill>
                   <a:schemeClr val="accent1"/>
                 </a:solidFill>
               </a:rPr>
-              <a:t>to ting</a:t>
-            </a:r>
-            <a:pPr algn="l" indent="0" marL="0">
+              <a:t>I JOBBET</a:t>
+            </a:r>
+            <a:endParaRPr lang="en-US" sz="1200" dirty="0"/>
+          </a:p>
+        </p:txBody>
+      </p:sp>
+      <p:sp>
+        <p:nvSpPr>
+          <p:cNvPr id="7" name="Text 5"/>
+          <p:cNvSpPr txBox="1"/>
+          <p:nvPr/>
+        </p:nvSpPr>
+        <p:spPr>
+          <a:xfrm>
+            <a:off x="6644488" y="2103120"/>
+            <a:ext cx="4998568" cy="2194560"/>
+          </a:xfrm>
+          <a:prstGeom prst="rect">
+            <a:avLst/>
+          </a:prstGeom>
+          <a:noFill/>
+          <a:ln/>
+        </p:spPr>
+        <p:txBody>
+          <a:bodyPr wrap="square" lIns="0" tIns="0" rIns="0" bIns="0" rtlCol="0" anchor="t"/>
+          <a:lstStyle/>
+          <a:p>
+            <a:pPr indent="0" marL="0">
               <a:lnSpc>
-                <a:spcPct val="93000"/>
+                <a:spcPct val="90000"/>
               </a:lnSpc>
               <a:buNone/>
             </a:pPr>
             <a:r>
-              <a:rPr lang="en-US" sz="3400" b="1" dirty="0">
-                <a:solidFill>
-                  <a:schemeClr val="tx1"/>
-                </a:solidFill>
-              </a:rPr>
-              <a:t>, før du går</a:t>
-            </a:r>
-            <a:endParaRPr lang="en-US" sz="3400" dirty="0"/>
-          </a:p>
-        </p:txBody>
-      </p:sp>
-      <p:sp>
-        <p:nvSpPr>
-          <p:cNvPr id="4" name="Text 2"/>
-          <p:cNvSpPr txBox="1"/>
-          <p:nvPr/>
-        </p:nvSpPr>
-        <p:spPr>
-          <a:xfrm>
-            <a:off x="685800" y="2377440"/>
-            <a:ext cx="914400" cy="1097280"/>
-          </a:xfrm>
-          <a:prstGeom prst="rect">
-            <a:avLst/>
-          </a:prstGeom>
-          <a:noFill/>
-          <a:ln/>
-        </p:spPr>
-        <p:txBody>
-          <a:bodyPr wrap="square" lIns="0" tIns="0" rIns="0" bIns="0" rtlCol="0" anchor="t"/>
-          <a:lstStyle/>
-          <a:p>
-            <a:pPr indent="0" marL="0">
-              <a:buNone/>
-            </a:pPr>
-            <a:r>
-              <a:rPr lang="en-US" sz="8000" b="1" dirty="0">
+              <a:rPr lang="en-US" sz="6400" b="1" dirty="0">
+                <a:solidFill>
+                  <a:schemeClr val="bg1"/>
+                </a:solidFill>
+              </a:rPr>
+              <a:t>Brug AI</a:t>
+            </a:r>
+            <a:endParaRPr lang="en-US" sz="6400" dirty="0"/>
+          </a:p>
+          <a:p>
+            <a:pPr indent="0" marL="0">
+              <a:lnSpc>
+                <a:spcPct val="90000"/>
+              </a:lnSpc>
+              <a:buNone/>
+            </a:pPr>
+            <a:r>
+              <a:rPr lang="en-US" sz="6400" b="1" dirty="0">
                 <a:solidFill>
                   <a:schemeClr val="accent1"/>
                 </a:solidFill>
               </a:rPr>
-              <a:t>1</a:t>
-            </a:r>
-            <a:endParaRPr lang="en-US" sz="8000" dirty="0"/>
-          </a:p>
-        </p:txBody>
-      </p:sp>
-      <p:sp>
-        <p:nvSpPr>
-          <p:cNvPr id="5" name="Text 3"/>
-          <p:cNvSpPr txBox="1"/>
-          <p:nvPr/>
-        </p:nvSpPr>
-        <p:spPr>
-          <a:xfrm>
-            <a:off x="1874520" y="2606040"/>
-            <a:ext cx="8686800" cy="1097280"/>
-          </a:xfrm>
-          <a:prstGeom prst="rect">
-            <a:avLst/>
-          </a:prstGeom>
-          <a:noFill/>
-          <a:ln/>
-        </p:spPr>
-        <p:txBody>
-          <a:bodyPr wrap="square" lIns="0" tIns="0" rIns="0" bIns="0" rtlCol="0" anchor="t"/>
-          <a:lstStyle/>
-          <a:p>
-            <a:pPr indent="0" marL="0">
-              <a:buNone/>
-            </a:pPr>
-            <a:r>
-              <a:rPr lang="en-US" sz="2800" b="1" dirty="0">
-                <a:solidFill>
-                  <a:schemeClr val="tx1"/>
-                </a:solidFill>
-              </a:rPr>
-              <a:t>Én arbejdsgang fra i dag, du vil bruge i dit studiejob eller din praktik.</a:t>
-            </a:r>
-            <a:endParaRPr lang="en-US" sz="2800" dirty="0"/>
-          </a:p>
-        </p:txBody>
-      </p:sp>
-      <p:sp>
-        <p:nvSpPr>
-          <p:cNvPr id="6" name="Text 4"/>
-          <p:cNvSpPr txBox="1"/>
-          <p:nvPr/>
-        </p:nvSpPr>
-        <p:spPr>
-          <a:xfrm>
-            <a:off x="685800" y="3977640"/>
-            <a:ext cx="914400" cy="1097280"/>
-          </a:xfrm>
-          <a:prstGeom prst="rect">
-            <a:avLst/>
-          </a:prstGeom>
-          <a:noFill/>
-          <a:ln/>
-        </p:spPr>
-        <p:txBody>
-          <a:bodyPr wrap="square" lIns="0" tIns="0" rIns="0" bIns="0" rtlCol="0" anchor="t"/>
-          <a:lstStyle/>
-          <a:p>
-            <a:pPr indent="0" marL="0">
-              <a:buNone/>
-            </a:pPr>
-            <a:r>
-              <a:rPr lang="en-US" sz="8000" b="1" dirty="0">
-                <a:solidFill>
-                  <a:schemeClr val="accent1"/>
-                </a:solidFill>
-              </a:rPr>
-              <a:t>2</a:t>
-            </a:r>
-            <a:endParaRPr lang="en-US" sz="8000" dirty="0"/>
-          </a:p>
-        </p:txBody>
-      </p:sp>
-      <p:sp>
-        <p:nvSpPr>
-          <p:cNvPr id="7" name="Text 5"/>
-          <p:cNvSpPr txBox="1"/>
-          <p:nvPr/>
-        </p:nvSpPr>
-        <p:spPr>
-          <a:xfrm>
-            <a:off x="1874520" y="4206240"/>
-            <a:ext cx="8686800" cy="1097280"/>
-          </a:xfrm>
-          <a:prstGeom prst="rect">
-            <a:avLst/>
-          </a:prstGeom>
-          <a:noFill/>
-          <a:ln/>
-        </p:spPr>
-        <p:txBody>
-          <a:bodyPr wrap="square" lIns="0" tIns="0" rIns="0" bIns="0" rtlCol="0" anchor="t"/>
-          <a:lstStyle/>
-          <a:p>
-            <a:pPr indent="0" marL="0">
-              <a:buNone/>
-            </a:pPr>
-            <a:r>
-              <a:rPr lang="en-US" sz="2800" b="1" dirty="0">
-                <a:solidFill>
-                  <a:schemeClr val="tx1"/>
-                </a:solidFill>
-              </a:rPr>
-              <a:t>Én ting, du vil lære selv, før du lader AI gøre det.</a:t>
-            </a:r>
-            <a:endParaRPr lang="en-US" sz="2800" dirty="0"/>
+              <a:t>fuldt ud.</a:t>
+            </a:r>
+            <a:endParaRPr lang="en-US" sz="6400" dirty="0"/>
+          </a:p>
+        </p:txBody>
+      </p:sp>
+      <p:sp>
+        <p:nvSpPr>
+          <p:cNvPr id="8" name="Text 6"/>
+          <p:cNvSpPr txBox="1"/>
+          <p:nvPr/>
+        </p:nvSpPr>
+        <p:spPr>
+          <a:xfrm>
+            <a:off x="6644488" y="4526280"/>
+            <a:ext cx="4815688" cy="914400"/>
+          </a:xfrm>
+          <a:prstGeom prst="rect">
+            <a:avLst/>
+          </a:prstGeom>
+          <a:noFill/>
+          <a:ln/>
+        </p:spPr>
+        <p:txBody>
+          <a:bodyPr wrap="square" lIns="0" tIns="0" rIns="0" bIns="0" rtlCol="0" anchor="t"/>
+          <a:lstStyle/>
+          <a:p>
+            <a:pPr indent="0" marL="0">
+              <a:buNone/>
+            </a:pPr>
+            <a:r>
+              <a:rPr lang="en-US" sz="1900" dirty="0">
+                <a:solidFill>
+                  <a:schemeClr val="accent3"/>
+                </a:solidFill>
+              </a:rPr>
+              <a:t>Tag svarene. Kør arbejdsgangene. Byg dine egne værktøjer.</a:t>
+            </a:r>
+            <a:endParaRPr lang="en-US" sz="1900" dirty="0"/>
           </a:p>
         </p:txBody>
       </p:sp>
@@ -18976,6 +19268,280 @@
 <file path=ppt/slides/slide45.xml><?xml version="1.0" encoding="utf-8"?>
 <p:sld xmlns:a="http://schemas.openxmlformats.org/drawingml/2006/main" xmlns:r="http://schemas.openxmlformats.org/officeDocument/2006/relationships" xmlns:p="http://schemas.openxmlformats.org/presentationml/2006/main">
   <p:cSld name="Slide 45">
+    <p:spTree>
+      <p:nvGrpSpPr>
+        <p:cNvPr id="1" name=""/>
+        <p:cNvGrpSpPr/>
+        <p:nvPr/>
+      </p:nvGrpSpPr>
+      <p:grpSpPr>
+        <a:xfrm>
+          <a:off x="0" y="0"/>
+          <a:ext cx="0" cy="0"/>
+          <a:chOff x="0" y="0"/>
+          <a:chExt cx="0" cy="0"/>
+        </a:xfrm>
+      </p:grpSpPr>
+      <p:sp>
+        <p:nvSpPr>
+          <p:cNvPr id="2" name="Text 0"/>
+          <p:cNvSpPr txBox="1"/>
+          <p:nvPr/>
+        </p:nvSpPr>
+        <p:spPr>
+          <a:xfrm>
+            <a:off x="685800" y="411480"/>
+            <a:ext cx="8229600" cy="274320"/>
+          </a:xfrm>
+          <a:prstGeom prst="rect">
+            <a:avLst/>
+          </a:prstGeom>
+          <a:noFill/>
+          <a:ln/>
+        </p:spPr>
+        <p:txBody>
+          <a:bodyPr wrap="square" lIns="0" tIns="0" rIns="0" bIns="0" rtlCol="0" anchor="t"/>
+          <a:lstStyle/>
+          <a:p>
+            <a:pPr indent="0" marL="0">
+              <a:buNone/>
+            </a:pPr>
+            <a:r>
+              <a:rPr lang="en-US" sz="1200" b="1" spc="200" kern="0" dirty="0">
+                <a:solidFill>
+                  <a:schemeClr val="accent2"/>
+                </a:solidFill>
+              </a:rPr>
+              <a:t>EXIT TICKET</a:t>
+            </a:r>
+            <a:endParaRPr lang="en-US" sz="1200" dirty="0"/>
+          </a:p>
+        </p:txBody>
+      </p:sp>
+      <p:sp>
+        <p:nvSpPr>
+          <p:cNvPr id="3" name="Text 0"/>
+          <p:cNvSpPr/>
+          <p:nvPr>
+            <p:ph idx="100" type="title" hasCustomPrompt="1"/>
+          </p:nvPr>
+        </p:nvSpPr>
+        <p:spPr>
+          <a:xfrm>
+            <a:off x="685800" y="804672"/>
+            <a:ext cx="10820095" cy="1280160"/>
+          </a:xfrm>
+          <a:prstGeom prst="rect">
+            <a:avLst/>
+          </a:prstGeom>
+          <a:noFill/>
+          <a:ln/>
+        </p:spPr>
+        <p:txBody>
+          <a:bodyPr wrap="square" lIns="0" tIns="0" rIns="0" bIns="0" rtlCol="0" anchor="t"/>
+          <a:lstStyle/>
+          <a:p>
+            <a:pPr algn="l" indent="0" marL="0">
+              <a:lnSpc>
+                <a:spcPct val="93000"/>
+              </a:lnSpc>
+              <a:buNone/>
+            </a:pPr>
+            <a:r>
+              <a:rPr lang="en-US" sz="3400" b="1" dirty="0">
+                <a:solidFill>
+                  <a:schemeClr val="tx1"/>
+                </a:solidFill>
+              </a:rPr>
+              <a:t>Skriv </a:t>
+            </a:r>
+            <a:pPr algn="l" indent="0" marL="0">
+              <a:lnSpc>
+                <a:spcPct val="93000"/>
+              </a:lnSpc>
+              <a:buNone/>
+            </a:pPr>
+            <a:r>
+              <a:rPr lang="en-US" sz="3400" b="1" dirty="0">
+                <a:solidFill>
+                  <a:schemeClr val="accent1"/>
+                </a:solidFill>
+              </a:rPr>
+              <a:t>to ting</a:t>
+            </a:r>
+            <a:pPr algn="l" indent="0" marL="0">
+              <a:lnSpc>
+                <a:spcPct val="93000"/>
+              </a:lnSpc>
+              <a:buNone/>
+            </a:pPr>
+            <a:r>
+              <a:rPr lang="en-US" sz="3400" b="1" dirty="0">
+                <a:solidFill>
+                  <a:schemeClr val="tx1"/>
+                </a:solidFill>
+              </a:rPr>
+              <a:t>, før du går</a:t>
+            </a:r>
+            <a:endParaRPr lang="en-US" sz="3400" dirty="0"/>
+          </a:p>
+        </p:txBody>
+      </p:sp>
+      <p:sp>
+        <p:nvSpPr>
+          <p:cNvPr id="4" name="Text 2"/>
+          <p:cNvSpPr txBox="1"/>
+          <p:nvPr/>
+        </p:nvSpPr>
+        <p:spPr>
+          <a:xfrm>
+            <a:off x="685800" y="2377440"/>
+            <a:ext cx="914400" cy="1097280"/>
+          </a:xfrm>
+          <a:prstGeom prst="rect">
+            <a:avLst/>
+          </a:prstGeom>
+          <a:noFill/>
+          <a:ln/>
+        </p:spPr>
+        <p:txBody>
+          <a:bodyPr wrap="square" lIns="0" tIns="0" rIns="0" bIns="0" rtlCol="0" anchor="t"/>
+          <a:lstStyle/>
+          <a:p>
+            <a:pPr indent="0" marL="0">
+              <a:buNone/>
+            </a:pPr>
+            <a:r>
+              <a:rPr lang="en-US" sz="8000" b="1" dirty="0">
+                <a:solidFill>
+                  <a:schemeClr val="accent1"/>
+                </a:solidFill>
+              </a:rPr>
+              <a:t>1</a:t>
+            </a:r>
+            <a:endParaRPr lang="en-US" sz="8000" dirty="0"/>
+          </a:p>
+        </p:txBody>
+      </p:sp>
+      <p:sp>
+        <p:nvSpPr>
+          <p:cNvPr id="5" name="Text 3"/>
+          <p:cNvSpPr txBox="1"/>
+          <p:nvPr/>
+        </p:nvSpPr>
+        <p:spPr>
+          <a:xfrm>
+            <a:off x="1874520" y="2606040"/>
+            <a:ext cx="8686800" cy="1097280"/>
+          </a:xfrm>
+          <a:prstGeom prst="rect">
+            <a:avLst/>
+          </a:prstGeom>
+          <a:noFill/>
+          <a:ln/>
+        </p:spPr>
+        <p:txBody>
+          <a:bodyPr wrap="square" lIns="0" tIns="0" rIns="0" bIns="0" rtlCol="0" anchor="t"/>
+          <a:lstStyle/>
+          <a:p>
+            <a:pPr indent="0" marL="0">
+              <a:buNone/>
+            </a:pPr>
+            <a:r>
+              <a:rPr lang="en-US" sz="2800" b="1" dirty="0">
+                <a:solidFill>
+                  <a:schemeClr val="tx1"/>
+                </a:solidFill>
+              </a:rPr>
+              <a:t>Én arbejdsgang fra i dag, du vil bruge i dit studiejob eller din praktik.</a:t>
+            </a:r>
+            <a:endParaRPr lang="en-US" sz="2800" dirty="0"/>
+          </a:p>
+        </p:txBody>
+      </p:sp>
+      <p:sp>
+        <p:nvSpPr>
+          <p:cNvPr id="6" name="Text 4"/>
+          <p:cNvSpPr txBox="1"/>
+          <p:nvPr/>
+        </p:nvSpPr>
+        <p:spPr>
+          <a:xfrm>
+            <a:off x="685800" y="3977640"/>
+            <a:ext cx="914400" cy="1097280"/>
+          </a:xfrm>
+          <a:prstGeom prst="rect">
+            <a:avLst/>
+          </a:prstGeom>
+          <a:noFill/>
+          <a:ln/>
+        </p:spPr>
+        <p:txBody>
+          <a:bodyPr wrap="square" lIns="0" tIns="0" rIns="0" bIns="0" rtlCol="0" anchor="t"/>
+          <a:lstStyle/>
+          <a:p>
+            <a:pPr indent="0" marL="0">
+              <a:buNone/>
+            </a:pPr>
+            <a:r>
+              <a:rPr lang="en-US" sz="8000" b="1" dirty="0">
+                <a:solidFill>
+                  <a:schemeClr val="accent1"/>
+                </a:solidFill>
+              </a:rPr>
+              <a:t>2</a:t>
+            </a:r>
+            <a:endParaRPr lang="en-US" sz="8000" dirty="0"/>
+          </a:p>
+        </p:txBody>
+      </p:sp>
+      <p:sp>
+        <p:nvSpPr>
+          <p:cNvPr id="7" name="Text 5"/>
+          <p:cNvSpPr txBox="1"/>
+          <p:nvPr/>
+        </p:nvSpPr>
+        <p:spPr>
+          <a:xfrm>
+            <a:off x="1874520" y="4206240"/>
+            <a:ext cx="8686800" cy="1097280"/>
+          </a:xfrm>
+          <a:prstGeom prst="rect">
+            <a:avLst/>
+          </a:prstGeom>
+          <a:noFill/>
+          <a:ln/>
+        </p:spPr>
+        <p:txBody>
+          <a:bodyPr wrap="square" lIns="0" tIns="0" rIns="0" bIns="0" rtlCol="0" anchor="t"/>
+          <a:lstStyle/>
+          <a:p>
+            <a:pPr indent="0" marL="0">
+              <a:buNone/>
+            </a:pPr>
+            <a:r>
+              <a:rPr lang="en-US" sz="2800" b="1" dirty="0">
+                <a:solidFill>
+                  <a:schemeClr val="tx1"/>
+                </a:solidFill>
+              </a:rPr>
+              <a:t>Én ting, du vil lære selv, før du lader AI gøre det.</a:t>
+            </a:r>
+            <a:endParaRPr lang="en-US" sz="2800" dirty="0"/>
+          </a:p>
+        </p:txBody>
+      </p:sp>
+    </p:spTree>
+  </p:cSld>
+  <p:clrMapOvr>
+    <a:masterClrMapping/>
+  </p:clrMapOvr>
+</p:sld>
+</file>
+
+<file path=ppt/slides/slide46.xml><?xml version="1.0" encoding="utf-8"?>
+<p:sld xmlns:a="http://schemas.openxmlformats.org/drawingml/2006/main" xmlns:r="http://schemas.openxmlformats.org/officeDocument/2006/relationships" xmlns:p="http://schemas.openxmlformats.org/presentationml/2006/main">
+  <p:cSld name="Slide 46">
     <p:bg>
       <p:bgPr>
         <a:blipFill dpi="0" rotWithShape="1">

</xml_diff>